<commit_message>
Update technical architecture presentation to reflect final deployed state
Refreshed Ponpoko-Technical-Architecture.pptx to match the actual final build: all 8/8 tickets
merged, real Azure resource footprint (VNet, private endpoint, private DNS zone, user-assigned
managed identity — 10 resources across 5 categories, not the original 4), Azure AD auth for the
leaderboard, the live production URL, and the post-launch root-redirect fix. Visually QA'd (fixed
one text/box overlap on the system architecture slide) via rendered slide images.

Co-authored-by: Copilot <223556219+Copilot@users.noreply.github.com>
</commit_message>
<xml_diff>
--- a/Ponpoko-Technical-Architecture.pptx
+++ b/Ponpoko-Technical-Architecture.pptx
@@ -142,7 +142,7 @@
                 </a:solidFill>
                 <a:latin typeface="Arial"/>
               </a:rPr>
-              <a:t>Resources provisioned (count)</a:t>
+              <a:t>10 resources across 5 categories</a:t>
             </a:r>
           </a:p>
         </c:rich>
@@ -166,7 +166,7 @@
               <c:strCache>
                 <c:ptCount val="1"/>
                 <c:pt idx="0">
-                  <c:v>SKU tier (relative cost index)</c:v>
+                  <c:v>Resources by category</c:v>
                 </c:pt>
               </c:strCache>
             </c:strRef>
@@ -195,7 +195,7 @@
               </a:p>
             </c:txPr>
             <c:showLegendKey val="0"/>
-            <c:showVal val="0"/>
+            <c:showVal val="1"/>
             <c:showCatName val="0"/>
             <c:showSerName val="0"/>
             <c:showPercent val="0"/>
@@ -204,21 +204,24 @@
           </c:dLbls>
           <c:cat>
             <c:multiLvlStrRef>
-              <c:f>Sheet1!$A$2:$A$5</c:f>
+              <c:f>Sheet1!$A$2:$A$6</c:f>
               <c:multiLvlStrCache>
-                <c:ptCount val="4"/>
+                <c:ptCount val="5"/>
                 <c:lvl>
                   <c:pt idx="0">
-                    <c:v>Container Apps</c:v>
+                    <c:v>Compute</c:v>
                   </c:pt>
                   <c:pt idx="1">
-                    <c:v>Container Registry</c:v>
+                    <c:v>Networking</c:v>
                   </c:pt>
                   <c:pt idx="2">
-                    <c:v>Storage Account</c:v>
+                    <c:v>Storage</c:v>
                   </c:pt>
                   <c:pt idx="3">
-                    <c:v>Log Analytics</c:v>
+                    <c:v>Identity</c:v>
+                  </c:pt>
+                  <c:pt idx="4">
+                    <c:v>Monitoring</c:v>
                   </c:pt>
                 </c:lvl>
               </c:multiLvlStrCache>
@@ -226,20 +229,23 @@
           </c:cat>
           <c:val>
             <c:numRef>
-              <c:f>Sheet1!$B$2:$B$5</c:f>
+              <c:f>Sheet1!$B$2:$B$6</c:f>
               <c:numCache>
                 <c:formatCode>General</c:formatCode>
-                <c:ptCount val="4"/>
+                <c:ptCount val="5"/>
                 <c:pt idx="0">
+                  <c:v>2</c:v>
+                </c:pt>
+                <c:pt idx="1">
+                  <c:v>4</c:v>
+                </c:pt>
+                <c:pt idx="2">
+                  <c:v>2</c:v>
+                </c:pt>
+                <c:pt idx="3">
                   <c:v>1</c:v>
                 </c:pt>
-                <c:pt idx="1">
-                  <c:v>1</c:v>
-                </c:pt>
-                <c:pt idx="2">
-                  <c:v>1</c:v>
-                </c:pt>
-                <c:pt idx="3">
+                <c:pt idx="4">
                   <c:v>1</c:v>
                 </c:pt>
               </c:numCache>
@@ -263,7 +269,7 @@
             </a:p>
           </c:txPr>
           <c:showLegendKey val="0"/>
-          <c:showVal val="0"/>
+          <c:showVal val="1"/>
           <c:showCatName val="0"/>
           <c:showSerName val="0"/>
           <c:showPercent val="0"/>
@@ -417,7 +423,7 @@
                 </a:solidFill>
                 <a:latin typeface="Arial"/>
               </a:rPr>
-              <a:t>Ticket status (6 of 8 merged)</a:t>
+              <a:t>Ticket status (8 of 8 merged)</a:t>
             </a:r>
           </a:p>
         </c:rich>
@@ -462,17 +468,7 @@
             <c:bubble3D val="0"/>
             <c:spPr>
               <a:solidFill>
-                <a:srgbClr val="F96167"/>
-              </a:solidFill>
-              <a:effectLst/>
-            </c:spPr>
-          </c:dPt>
-          <c:dPt>
-            <c:idx val="1"/>
-            <c:bubble3D val="0"/>
-            <c:spPr>
-              <a:solidFill>
-                <a:srgbClr val="3E4670"/>
+                <a:srgbClr val="3FA796"/>
               </a:solidFill>
               <a:effectLst/>
             </c:spPr>
@@ -480,31 +476,6 @@
           <c:dLbls>
             <c:dLbl>
               <c:idx val="0"/>
-              <c:numFmt formatCode="General" sourceLinked="0"/>
-              <c:spPr/>
-              <c:txPr>
-                <a:bodyPr/>
-                <a:lstStyle/>
-                <a:p>
-                  <a:pPr>
-                    <a:defRPr sz="1200" b="0" i="0" u="none" strike="noStrike">
-                      <a:solidFill>
-                        <a:srgbClr val="FFFFFF"/>
-                      </a:solidFill>
-                      <a:latin typeface="Arial"/>
-                    </a:defRPr>
-                  </a:pPr>
-                </a:p>
-              </c:txPr>
-              <c:showLegendKey val="0"/>
-              <c:showVal val="1"/>
-              <c:showCatName val="0"/>
-              <c:showSerName val="0"/>
-              <c:showPercent val="0"/>
-              <c:showBubbleSize val="0"/>
-            </c:dLbl>
-            <c:dLbl>
-              <c:idx val="1"/>
               <c:numFmt formatCode="General" sourceLinked="0"/>
               <c:spPr/>
               <c:txPr>
@@ -553,28 +524,22 @@
           </c:dLbls>
           <c:cat>
             <c:strRef>
-              <c:f>Sheet1!$A$2:$A$3</c:f>
+              <c:f>Sheet1!$A$2:$A$2</c:f>
               <c:strCache>
-                <c:ptCount val="2"/>
+                <c:ptCount val="1"/>
                 <c:pt idx="0">
                   <c:v>Merged</c:v>
-                </c:pt>
-                <c:pt idx="1">
-                  <c:v>In review / remaining</c:v>
                 </c:pt>
               </c:strCache>
             </c:strRef>
           </c:cat>
           <c:val>
             <c:numRef>
-              <c:f>Sheet1!$B$2:$B$3</c:f>
+              <c:f>Sheet1!$B$2:$B$2</c:f>
               <c:numCache>
-                <c:ptCount val="2"/>
+                <c:ptCount val="1"/>
                 <c:pt idx="0">
-                  <c:v>6</c:v>
-                </c:pt>
-                <c:pt idx="1">
-                  <c:v>2</c:v>
+                  <c:v>8</c:v>
                 </c:pt>
               </c:numCache>
             </c:numRef>
@@ -2231,7 +2196,7 @@
         </p:nvSpPr>
         <p:spPr>
           <a:xfrm>
-            <a:off x="640080" y="2103120"/>
+            <a:off x="640080" y="1920240"/>
             <a:ext cx="9144000" cy="1005840"/>
           </a:xfrm>
           <a:prstGeom prst="rect">
@@ -2270,7 +2235,7 @@
         </p:nvSpPr>
         <p:spPr>
           <a:xfrm>
-            <a:off x="640080" y="3108960"/>
+            <a:off x="640080" y="2926080"/>
             <a:ext cx="9144000" cy="548640"/>
           </a:xfrm>
           <a:prstGeom prst="rect">
@@ -2303,7 +2268,68 @@
       </p:sp>
       <p:sp>
         <p:nvSpPr>
-          <p:cNvPr id="6" name="Text 4"/>
+          <p:cNvPr id="6" name="Shape 4"/>
+          <p:cNvSpPr/>
+          <p:nvPr/>
+        </p:nvSpPr>
+        <p:spPr>
+          <a:xfrm>
+            <a:off x="640080" y="3657600"/>
+            <a:ext cx="4206240" cy="502920"/>
+          </a:xfrm>
+          <a:prstGeom prst="roundRect">
+            <a:avLst>
+              <a:gd name="adj" fmla="val 14545"/>
+            </a:avLst>
+          </a:prstGeom>
+          <a:solidFill>
+            <a:srgbClr val="3FA796"/>
+          </a:solidFill>
+          <a:ln/>
+        </p:spPr>
+      </p:sp>
+      <p:sp>
+        <p:nvSpPr>
+          <p:cNvPr id="7" name="Text 5"/>
+          <p:cNvSpPr/>
+          <p:nvPr/>
+        </p:nvSpPr>
+        <p:spPr>
+          <a:xfrm>
+            <a:off x="640080" y="3657600"/>
+            <a:ext cx="4206240" cy="502920"/>
+          </a:xfrm>
+          <a:prstGeom prst="rect">
+            <a:avLst/>
+          </a:prstGeom>
+          <a:noFill/>
+          <a:ln/>
+        </p:spPr>
+        <p:txBody>
+          <a:bodyPr wrap="square" lIns="0" tIns="0" rIns="0" bIns="0" rtlCol="0" anchor="ctr"/>
+          <a:lstStyle/>
+          <a:p>
+            <a:pPr algn="ctr" indent="0" marL="0">
+              <a:buNone/>
+            </a:pPr>
+            <a:r>
+              <a:rPr lang="en-US" sz="1400" b="1" dirty="0">
+                <a:solidFill>
+                  <a:srgbClr val="FFFFFF"/>
+                </a:solidFill>
+                <a:latin typeface="Trebuchet MS" pitchFamily="34" charset="0"/>
+                <a:ea typeface="Trebuchet MS" pitchFamily="34" charset="-122"/>
+                <a:cs typeface="Trebuchet MS" pitchFamily="34" charset="-120"/>
+              </a:rPr>
+              <a:t>LIVE IN PRODUCTION — 8/8 tickets shipped</a:t>
+            </a:r>
+            <a:endParaRPr lang="en-US" sz="1400" dirty="0"/>
+          </a:p>
+        </p:txBody>
+      </p:sp>
+      <p:sp>
+        <p:nvSpPr>
+          <p:cNvPr id="8" name="Text 6"/>
           <p:cNvSpPr/>
           <p:nvPr/>
         </p:nvSpPr>
@@ -2420,7 +2446,7 @@
         <p:spPr>
           <a:xfrm>
             <a:off x="640080" y="1371600"/>
-            <a:ext cx="10881360" cy="2926080"/>
+            <a:ext cx="10881360" cy="3291840"/>
           </a:xfrm>
           <a:prstGeom prst="rect">
             <a:avLst/>
@@ -2437,7 +2463,7 @@
               <a:buChar char="•"/>
             </a:pPr>
             <a:r>
-              <a:rPr lang="en-US" sz="1600" dirty="0">
+              <a:rPr lang="en-US" sz="1550" dirty="0">
                 <a:solidFill>
                   <a:srgbClr val="EAF4F4"/>
                 </a:solidFill>
@@ -2447,7 +2473,7 @@
               </a:rPr>
               <a:t>Planning: 5/5 architecture decisions resolved, 3 ADRs recorded</a:t>
             </a:r>
-            <a:endParaRPr lang="en-US" sz="1600" dirty="0"/>
+            <a:endParaRPr lang="en-US" sz="1550" dirty="0"/>
           </a:p>
           <a:p>
             <a:pPr marL="342900" indent="-342900">
@@ -2455,7 +2481,7 @@
               <a:buChar char="•"/>
             </a:pPr>
             <a:r>
-              <a:rPr lang="en-US" sz="1600" dirty="0">
+              <a:rPr lang="en-US" sz="1550" dirty="0">
                 <a:solidFill>
                   <a:srgbClr val="EAF4F4"/>
                 </a:solidFill>
@@ -2465,7 +2491,7 @@
               </a:rPr>
               <a:t>Game: full arcade loop — movement, jump, climbing, enemies, lives, scoring, synthesized audio</a:t>
             </a:r>
-            <a:endParaRPr lang="en-US" sz="1600" dirty="0"/>
+            <a:endParaRPr lang="en-US" sz="1550" dirty="0"/>
           </a:p>
           <a:p>
             <a:pPr marL="342900" indent="-342900">
@@ -2473,7 +2499,7 @@
               <a:buChar char="•"/>
             </a:pPr>
             <a:r>
-              <a:rPr lang="en-US" sz="1600" dirty="0">
+              <a:rPr lang="en-US" sz="1550" dirty="0">
                 <a:solidFill>
                   <a:srgbClr val="EAF4F4"/>
                 </a:solidFill>
@@ -2481,9 +2507,9 @@
                 <a:ea typeface="Calibri" pitchFamily="34" charset="-122"/>
                 <a:cs typeface="Calibri" pitchFamily="34" charset="-120"/>
               </a:rPr>
-              <a:t>Leaderboard: Azure Table Storage-backed, validated &amp; rate-limited API</a:t>
-            </a:r>
-            <a:endParaRPr lang="en-US" sz="1600" dirty="0"/>
+              <a:t>Leaderboard: Azure Table Storage, Azure AD auth, private endpoint, rate-limited API</a:t>
+            </a:r>
+            <a:endParaRPr lang="en-US" sz="1550" dirty="0"/>
           </a:p>
           <a:p>
             <a:pPr marL="342900" indent="-342900">
@@ -2491,7 +2517,7 @@
               <a:buChar char="•"/>
             </a:pPr>
             <a:r>
-              <a:rPr lang="en-US" sz="1600" dirty="0">
+              <a:rPr lang="en-US" sz="1550" dirty="0">
                 <a:solidFill>
                   <a:srgbClr val="EAF4F4"/>
                 </a:solidFill>
@@ -2499,9 +2525,9 @@
                 <a:ea typeface="Calibri" pitchFamily="34" charset="-122"/>
                 <a:cs typeface="Calibri" pitchFamily="34" charset="-120"/>
               </a:rPr>
-              <a:t>Packaging: 286MB multi-stage Docker image, non-root, verified end-to-end locally</a:t>
-            </a:r>
-            <a:endParaRPr lang="en-US" sz="1600" dirty="0"/>
+              <a:t>Packaging: 286MB multi-stage Docker image, non-root, verified end-to-end</a:t>
+            </a:r>
+            <a:endParaRPr lang="en-US" sz="1550" dirty="0"/>
           </a:p>
           <a:p>
             <a:pPr marL="342900" indent="-342900">
@@ -2509,7 +2535,7 @@
               <a:buChar char="•"/>
             </a:pPr>
             <a:r>
-              <a:rPr lang="en-US" sz="1600" dirty="0">
+              <a:rPr lang="en-US" sz="1550" dirty="0">
                 <a:solidFill>
                   <a:srgbClr val="EAF4F4"/>
                 </a:solidFill>
@@ -2517,9 +2543,9 @@
                 <a:ea typeface="Calibri" pitchFamily="34" charset="-122"/>
                 <a:cs typeface="Calibri" pitchFamily="34" charset="-120"/>
               </a:rPr>
-              <a:t>Infra: Bicep + azd, single-replica Container Apps, OIDC CI/CD — in final review</a:t>
-            </a:r>
-            <a:endParaRPr lang="en-US" sz="1600" dirty="0"/>
+              <a:t>Infra: Bicep + azd, VNet + private endpoint, single-replica Container Apps, OIDC CI/CD</a:t>
+            </a:r>
+            <a:endParaRPr lang="en-US" sz="1550" dirty="0"/>
           </a:p>
           <a:p>
             <a:pPr marL="342900" indent="-342900">
@@ -2527,7 +2553,7 @@
               <a:buChar char="•"/>
             </a:pPr>
             <a:r>
-              <a:rPr lang="en-US" sz="1600" dirty="0">
+              <a:rPr lang="en-US" sz="1550" dirty="0">
                 <a:solidFill>
                   <a:srgbClr val="EAF4F4"/>
                 </a:solidFill>
@@ -2535,9 +2561,27 @@
                 <a:ea typeface="Calibri" pitchFamily="34" charset="-122"/>
                 <a:cs typeface="Calibri" pitchFamily="34" charset="-120"/>
               </a:rPr>
-              <a:t>Quality: 40 unit tests, every PR independently rebuilt/retested/reviewed before merge</a:t>
-            </a:r>
-            <a:endParaRPr lang="en-US" sz="1600" dirty="0"/>
+              <a:t>Quality: 40 unit tests, every PR independently rebuilt/retested/reviewed, live smoke test passing</a:t>
+            </a:r>
+            <a:endParaRPr lang="en-US" sz="1550" dirty="0"/>
+          </a:p>
+          <a:p>
+            <a:pPr marL="342900" indent="-342900">
+              <a:buSzPct val="100000"/>
+              <a:buChar char="•"/>
+            </a:pPr>
+            <a:r>
+              <a:rPr lang="en-US" sz="1550" b="1" dirty="0">
+                <a:solidFill>
+                  <a:srgbClr val="EAF4F4"/>
+                </a:solidFill>
+                <a:latin typeface="Calibri" pitchFamily="34" charset="0"/>
+                <a:ea typeface="Calibri" pitchFamily="34" charset="-122"/>
+                <a:cs typeface="Calibri" pitchFamily="34" charset="-120"/>
+              </a:rPr>
+              <a:t>Status: DEPLOYED AND VERIFIED IN PRODUCTION</a:t>
+            </a:r>
+            <a:endParaRPr lang="en-US" sz="1550" dirty="0"/>
           </a:p>
         </p:txBody>
       </p:sp>
@@ -2549,7 +2593,7 @@
         </p:nvSpPr>
         <p:spPr>
           <a:xfrm>
-            <a:off x="640080" y="4572000"/>
+            <a:off x="640080" y="4937760"/>
             <a:ext cx="10881360" cy="0"/>
           </a:xfrm>
           <a:prstGeom prst="line">
@@ -2572,8 +2616,8 @@
         </p:nvSpPr>
         <p:spPr>
           <a:xfrm>
-            <a:off x="640080" y="4846320"/>
-            <a:ext cx="10881360" cy="548640"/>
+            <a:off x="640080" y="5166360"/>
+            <a:ext cx="10881360" cy="1097280"/>
           </a:xfrm>
           <a:prstGeom prst="rect">
             <a:avLst/>
@@ -2589,7 +2633,7 @@
               <a:buNone/>
             </a:pPr>
             <a:r>
-              <a:rPr lang="en-US" sz="1500" i="1" dirty="0">
+              <a:rPr lang="en-US" sz="1300" i="1" dirty="0">
                 <a:solidFill>
                   <a:srgbClr val="F96167"/>
                 </a:solidFill>
@@ -2597,9 +2641,9 @@
                 <a:ea typeface="Calibri" pitchFamily="34" charset="-122"/>
                 <a:cs typeface="Calibri" pitchFamily="34" charset="-120"/>
               </a:rPr>
-              <a:t>Next: complete Azure provisioning, then a production smoke test against the live URL.</a:t>
-            </a:r>
-            <a:endParaRPr lang="en-US" sz="1500" dirty="0"/>
+              <a:t>This project also served as a case study in real-world Azure deployment troubleshooting: tenant governance policies (disabled shared-key auth, disabled public network access), azd/Bicep quirks, and RBAC propagation races were each diagnosed from live deployment logs and fixed, not guessed at.</a:t>
+            </a:r>
+            <a:endParaRPr lang="en-US" sz="1300" dirty="0"/>
           </a:p>
         </p:txBody>
       </p:sp>
@@ -2707,7 +2751,7 @@
                 <a:ea typeface="Calibri" pitchFamily="34" charset="-122"/>
                 <a:cs typeface="Calibri" pitchFamily="34" charset="-120"/>
               </a:rPr>
-              <a:t>Client browser through to Azure infrastructure</a:t>
+              <a:t>Client browser through to Azure infrastructure — now fully private-networked</a:t>
             </a:r>
             <a:endParaRPr lang="en-US" sz="1300" dirty="0"/>
           </a:p>
@@ -2721,12 +2765,12 @@
         </p:nvSpPr>
         <p:spPr>
           <a:xfrm>
-            <a:off x="548640" y="1463040"/>
-            <a:ext cx="11064240" cy="1417320"/>
+            <a:off x="548640" y="1325880"/>
+            <a:ext cx="11064240" cy="1051560"/>
           </a:xfrm>
           <a:prstGeom prst="roundRect">
             <a:avLst>
-              <a:gd name="adj" fmla="val 3871"/>
+              <a:gd name="adj" fmla="val 5217"/>
             </a:avLst>
           </a:prstGeom>
           <a:solidFill>
@@ -2743,8 +2787,8 @@
         </p:nvSpPr>
         <p:spPr>
           <a:xfrm>
-            <a:off x="822960" y="1554480"/>
-            <a:ext cx="10515600" cy="365760"/>
+            <a:off x="822960" y="1380744"/>
+            <a:ext cx="10515600" cy="274320"/>
           </a:xfrm>
           <a:prstGeom prst="rect">
             <a:avLst/>
@@ -2760,7 +2804,7 @@
               <a:buNone/>
             </a:pPr>
             <a:r>
-              <a:rPr lang="en-US" sz="1500" b="1" dirty="0">
+              <a:rPr lang="en-US" sz="1250" b="1" dirty="0">
                 <a:solidFill>
                   <a:srgbClr val="FFFFFF"/>
                 </a:solidFill>
@@ -2770,7 +2814,7 @@
               </a:rPr>
               <a:t>CLIENT (Browser)</a:t>
             </a:r>
-            <a:endParaRPr lang="en-US" sz="1500" dirty="0"/>
+            <a:endParaRPr lang="en-US" sz="1250" dirty="0"/>
           </a:p>
         </p:txBody>
       </p:sp>
@@ -2782,8 +2826,8 @@
         </p:nvSpPr>
         <p:spPr>
           <a:xfrm>
-            <a:off x="822960" y="1920240"/>
-            <a:ext cx="10332720" cy="868680"/>
+            <a:off x="822960" y="1655064"/>
+            <a:ext cx="10332720" cy="685800"/>
           </a:xfrm>
           <a:prstGeom prst="rect">
             <a:avLst/>
@@ -2800,7 +2844,7 @@
               <a:buChar char="•"/>
             </a:pPr>
             <a:r>
-              <a:rPr lang="en-US" sz="1200" dirty="0">
+              <a:rPr lang="en-US" sz="1000" dirty="0">
                 <a:solidFill>
                   <a:srgbClr val="EAF4F4"/>
                 </a:solidFill>
@@ -2810,7 +2854,7 @@
               </a:rPr>
               <a:t>Canvas game loop (RAF)</a:t>
             </a:r>
-            <a:endParaRPr lang="en-US" sz="1200" dirty="0"/>
+            <a:endParaRPr lang="en-US" sz="1000" dirty="0"/>
           </a:p>
           <a:p>
             <a:pPr marL="342900" indent="-342900">
@@ -2818,7 +2862,7 @@
               <a:buChar char="•"/>
             </a:pPr>
             <a:r>
-              <a:rPr lang="en-US" sz="1200" dirty="0">
+              <a:rPr lang="en-US" sz="1000" dirty="0">
                 <a:solidFill>
                   <a:srgbClr val="EAF4F4"/>
                 </a:solidFill>
@@ -2828,7 +2872,7 @@
               </a:rPr>
               <a:t>Web Audio synthesis</a:t>
             </a:r>
-            <a:endParaRPr lang="en-US" sz="1200" dirty="0"/>
+            <a:endParaRPr lang="en-US" sz="1000" dirty="0"/>
           </a:p>
           <a:p>
             <a:pPr marL="342900" indent="-342900">
@@ -2836,7 +2880,7 @@
               <a:buChar char="•"/>
             </a:pPr>
             <a:r>
-              <a:rPr lang="en-US" sz="1200" dirty="0">
+              <a:rPr lang="en-US" sz="1000" dirty="0">
                 <a:solidFill>
                   <a:srgbClr val="EAF4F4"/>
                 </a:solidFill>
@@ -2846,7 +2890,7 @@
               </a:rPr>
               <a:t>fetch() to API routes</a:t>
             </a:r>
-            <a:endParaRPr lang="en-US" sz="1200" dirty="0"/>
+            <a:endParaRPr lang="en-US" sz="1000" dirty="0"/>
           </a:p>
         </p:txBody>
       </p:sp>
@@ -2858,12 +2902,12 @@
         </p:nvSpPr>
         <p:spPr>
           <a:xfrm>
-            <a:off x="548640" y="3108960"/>
-            <a:ext cx="11064240" cy="1417320"/>
+            <a:off x="548640" y="2514600"/>
+            <a:ext cx="11064240" cy="1051560"/>
           </a:xfrm>
           <a:prstGeom prst="roundRect">
             <a:avLst>
-              <a:gd name="adj" fmla="val 3871"/>
+              <a:gd name="adj" fmla="val 5217"/>
             </a:avLst>
           </a:prstGeom>
           <a:solidFill>
@@ -2880,8 +2924,8 @@
         </p:nvSpPr>
         <p:spPr>
           <a:xfrm>
-            <a:off x="822960" y="3200400"/>
-            <a:ext cx="10515600" cy="365760"/>
+            <a:off x="822960" y="2569464"/>
+            <a:ext cx="10515600" cy="274320"/>
           </a:xfrm>
           <a:prstGeom prst="rect">
             <a:avLst/>
@@ -2897,7 +2941,7 @@
               <a:buNone/>
             </a:pPr>
             <a:r>
-              <a:rPr lang="en-US" sz="1500" b="1" dirty="0">
+              <a:rPr lang="en-US" sz="1250" b="1" dirty="0">
                 <a:solidFill>
                   <a:srgbClr val="FFFFFF"/>
                 </a:solidFill>
@@ -2905,9 +2949,9 @@
                 <a:ea typeface="Trebuchet MS" pitchFamily="34" charset="-122"/>
                 <a:cs typeface="Trebuchet MS" pitchFamily="34" charset="-120"/>
               </a:rPr>
-              <a:t>AZURE CONTAINER APPS — "ca-ponpoko-eval" (1 replica, port 3000)</a:t>
-            </a:r>
-            <a:endParaRPr lang="en-US" sz="1500" dirty="0"/>
+              <a:t>AZURE CONTAINER APPS — "ca-ponpoko-eval" (1 replica, VNet-integrated, port 3000)</a:t>
+            </a:r>
+            <a:endParaRPr lang="en-US" sz="1250" dirty="0"/>
           </a:p>
         </p:txBody>
       </p:sp>
@@ -2919,8 +2963,8 @@
         </p:nvSpPr>
         <p:spPr>
           <a:xfrm>
-            <a:off x="822960" y="3566160"/>
-            <a:ext cx="10332720" cy="868680"/>
+            <a:off x="822960" y="2843784"/>
+            <a:ext cx="10332720" cy="685800"/>
           </a:xfrm>
           <a:prstGeom prst="rect">
             <a:avLst/>
@@ -2937,7 +2981,7 @@
               <a:buChar char="•"/>
             </a:pPr>
             <a:r>
-              <a:rPr lang="en-US" sz="1200" dirty="0">
+              <a:rPr lang="en-US" sz="1000" dirty="0">
                 <a:solidFill>
                   <a:srgbClr val="EAF4F4"/>
                 </a:solidFill>
@@ -2947,7 +2991,7 @@
               </a:rPr>
               <a:t>Next.js 16 standalone server</a:t>
             </a:r>
-            <a:endParaRPr lang="en-US" sz="1200" dirty="0"/>
+            <a:endParaRPr lang="en-US" sz="1000" dirty="0"/>
           </a:p>
           <a:p>
             <a:pPr marL="342900" indent="-342900">
@@ -2955,7 +2999,7 @@
               <a:buChar char="•"/>
             </a:pPr>
             <a:r>
-              <a:rPr lang="en-US" sz="1200" dirty="0">
+              <a:rPr lang="en-US" sz="1000" dirty="0">
                 <a:solidFill>
                   <a:srgbClr val="EAF4F4"/>
                 </a:solidFill>
@@ -2965,7 +3009,7 @@
               </a:rPr>
               <a:t>App Router pages + API routes</a:t>
             </a:r>
-            <a:endParaRPr lang="en-US" sz="1200" dirty="0"/>
+            <a:endParaRPr lang="en-US" sz="1000" dirty="0"/>
           </a:p>
           <a:p>
             <a:pPr marL="342900" indent="-342900">
@@ -2973,7 +3017,7 @@
               <a:buChar char="•"/>
             </a:pPr>
             <a:r>
-              <a:rPr lang="en-US" sz="1200" dirty="0">
+              <a:rPr lang="en-US" sz="1000" dirty="0">
                 <a:solidFill>
                   <a:srgbClr val="EAF4F4"/>
                 </a:solidFill>
@@ -2981,9 +3025,9 @@
                 <a:ea typeface="Calibri" pitchFamily="34" charset="-122"/>
                 <a:cs typeface="Calibri" pitchFamily="34" charset="-120"/>
               </a:rPr>
-              <a:t>Non-root container user</a:t>
-            </a:r>
-            <a:endParaRPr lang="en-US" sz="1200" dirty="0"/>
+              <a:t>Non-root container user, user-assigned managed identity</a:t>
+            </a:r>
+            <a:endParaRPr lang="en-US" sz="1000" dirty="0"/>
           </a:p>
         </p:txBody>
       </p:sp>
@@ -2995,12 +3039,131 @@
         </p:nvSpPr>
         <p:spPr>
           <a:xfrm>
-            <a:off x="548640" y="4754880"/>
-            <a:ext cx="11064240" cy="1417320"/>
+            <a:off x="548640" y="3703320"/>
+            <a:ext cx="11064240" cy="1051560"/>
           </a:xfrm>
           <a:prstGeom prst="roundRect">
             <a:avLst>
-              <a:gd name="adj" fmla="val 3871"/>
+              <a:gd name="adj" fmla="val 5217"/>
+            </a:avLst>
+          </a:prstGeom>
+          <a:solidFill>
+            <a:srgbClr val="13405E"/>
+          </a:solidFill>
+          <a:ln/>
+        </p:spPr>
+      </p:sp>
+      <p:sp>
+        <p:nvSpPr>
+          <p:cNvPr id="11" name="Text 9"/>
+          <p:cNvSpPr/>
+          <p:nvPr/>
+        </p:nvSpPr>
+        <p:spPr>
+          <a:xfrm>
+            <a:off x="822960" y="3758184"/>
+            <a:ext cx="10515600" cy="274320"/>
+          </a:xfrm>
+          <a:prstGeom prst="rect">
+            <a:avLst/>
+          </a:prstGeom>
+          <a:noFill/>
+          <a:ln/>
+        </p:spPr>
+        <p:txBody>
+          <a:bodyPr wrap="square" lIns="0" tIns="0" rIns="0" bIns="0" rtlCol="0" anchor="ctr"/>
+          <a:lstStyle/>
+          <a:p>
+            <a:pPr indent="0" marL="0">
+              <a:buNone/>
+            </a:pPr>
+            <a:r>
+              <a:rPr lang="en-US" sz="1250" b="1" dirty="0">
+                <a:solidFill>
+                  <a:srgbClr val="FFFFFF"/>
+                </a:solidFill>
+                <a:latin typeface="Trebuchet MS" pitchFamily="34" charset="0"/>
+                <a:ea typeface="Trebuchet MS" pitchFamily="34" charset="-122"/>
+                <a:cs typeface="Trebuchet MS" pitchFamily="34" charset="-120"/>
+              </a:rPr>
+              <a:t>PRIVATE NETWORK — VNet "vnet-ponpoko-eval"</a:t>
+            </a:r>
+            <a:endParaRPr lang="en-US" sz="1250" dirty="0"/>
+          </a:p>
+        </p:txBody>
+      </p:sp>
+      <p:sp>
+        <p:nvSpPr>
+          <p:cNvPr id="12" name="Text 10"/>
+          <p:cNvSpPr/>
+          <p:nvPr/>
+        </p:nvSpPr>
+        <p:spPr>
+          <a:xfrm>
+            <a:off x="822960" y="4032504"/>
+            <a:ext cx="10332720" cy="685800"/>
+          </a:xfrm>
+          <a:prstGeom prst="rect">
+            <a:avLst/>
+          </a:prstGeom>
+          <a:noFill/>
+          <a:ln/>
+        </p:spPr>
+        <p:txBody>
+          <a:bodyPr wrap="square" lIns="0" tIns="0" rIns="0" bIns="0" rtlCol="0" anchor="ctr"/>
+          <a:lstStyle/>
+          <a:p>
+            <a:pPr marL="342900" indent="-342900">
+              <a:buSzPct val="100000"/>
+              <a:buChar char="•"/>
+            </a:pPr>
+            <a:r>
+              <a:rPr lang="en-US" sz="1000" dirty="0">
+                <a:solidFill>
+                  <a:srgbClr val="EAF4F4"/>
+                </a:solidFill>
+                <a:latin typeface="Calibri" pitchFamily="34" charset="0"/>
+                <a:ea typeface="Calibri" pitchFamily="34" charset="-122"/>
+                <a:cs typeface="Calibri" pitchFamily="34" charset="-120"/>
+              </a:rPr>
+              <a:t>Delegated subnet for the Container Apps environment</a:t>
+            </a:r>
+            <a:endParaRPr lang="en-US" sz="1000" dirty="0"/>
+          </a:p>
+          <a:p>
+            <a:pPr marL="342900" indent="-342900">
+              <a:buSzPct val="100000"/>
+              <a:buChar char="•"/>
+            </a:pPr>
+            <a:r>
+              <a:rPr lang="en-US" sz="1000" dirty="0">
+                <a:solidFill>
+                  <a:srgbClr val="EAF4F4"/>
+                </a:solidFill>
+                <a:latin typeface="Calibri" pitchFamily="34" charset="0"/>
+                <a:ea typeface="Calibri" pitchFamily="34" charset="-122"/>
+                <a:cs typeface="Calibri" pitchFamily="34" charset="-120"/>
+              </a:rPr>
+              <a:t>Private endpoint + private DNS zone for Table Storage (no public access)</a:t>
+            </a:r>
+            <a:endParaRPr lang="en-US" sz="1000" dirty="0"/>
+          </a:p>
+        </p:txBody>
+      </p:sp>
+      <p:sp>
+        <p:nvSpPr>
+          <p:cNvPr id="13" name="Shape 11"/>
+          <p:cNvSpPr/>
+          <p:nvPr/>
+        </p:nvSpPr>
+        <p:spPr>
+          <a:xfrm>
+            <a:off x="548640" y="4892040"/>
+            <a:ext cx="11064240" cy="1051560"/>
+          </a:xfrm>
+          <a:prstGeom prst="roundRect">
+            <a:avLst>
+              <a:gd name="adj" fmla="val 5217"/>
             </a:avLst>
           </a:prstGeom>
           <a:solidFill>
@@ -3011,14 +3174,14 @@
       </p:sp>
       <p:sp>
         <p:nvSpPr>
-          <p:cNvPr id="11" name="Text 9"/>
-          <p:cNvSpPr/>
-          <p:nvPr/>
-        </p:nvSpPr>
-        <p:spPr>
-          <a:xfrm>
-            <a:off x="822960" y="4846320"/>
-            <a:ext cx="10515600" cy="365760"/>
+          <p:cNvPr id="14" name="Text 12"/>
+          <p:cNvSpPr/>
+          <p:nvPr/>
+        </p:nvSpPr>
+        <p:spPr>
+          <a:xfrm>
+            <a:off x="822960" y="4946904"/>
+            <a:ext cx="10515600" cy="274320"/>
           </a:xfrm>
           <a:prstGeom prst="rect">
             <a:avLst/>
@@ -3034,7 +3197,7 @@
               <a:buNone/>
             </a:pPr>
             <a:r>
-              <a:rPr lang="en-US" sz="1500" b="1" dirty="0">
+              <a:rPr lang="en-US" sz="1250" b="1" dirty="0">
                 <a:solidFill>
                   <a:srgbClr val="FFFFFF"/>
                 </a:solidFill>
@@ -3044,20 +3207,20 @@
               </a:rPr>
               <a:t>AZURE PLATFORM SERVICES</a:t>
             </a:r>
-            <a:endParaRPr lang="en-US" sz="1500" dirty="0"/>
-          </a:p>
-        </p:txBody>
-      </p:sp>
-      <p:sp>
-        <p:nvSpPr>
-          <p:cNvPr id="12" name="Text 10"/>
-          <p:cNvSpPr/>
-          <p:nvPr/>
-        </p:nvSpPr>
-        <p:spPr>
-          <a:xfrm>
-            <a:off x="822960" y="5212080"/>
-            <a:ext cx="10332720" cy="868680"/>
+            <a:endParaRPr lang="en-US" sz="1250" dirty="0"/>
+          </a:p>
+        </p:txBody>
+      </p:sp>
+      <p:sp>
+        <p:nvSpPr>
+          <p:cNvPr id="15" name="Text 13"/>
+          <p:cNvSpPr/>
+          <p:nvPr/>
+        </p:nvSpPr>
+        <p:spPr>
+          <a:xfrm>
+            <a:off x="822960" y="5221224"/>
+            <a:ext cx="10332720" cy="685800"/>
           </a:xfrm>
           <a:prstGeom prst="rect">
             <a:avLst/>
@@ -3074,7 +3237,7 @@
               <a:buChar char="•"/>
             </a:pPr>
             <a:r>
-              <a:rPr lang="en-US" sz="1200" dirty="0">
+              <a:rPr lang="en-US" sz="1000" dirty="0">
                 <a:solidFill>
                   <a:srgbClr val="EAF4F4"/>
                 </a:solidFill>
@@ -3082,9 +3245,9 @@
                 <a:ea typeface="Calibri" pitchFamily="34" charset="-122"/>
                 <a:cs typeface="Calibri" pitchFamily="34" charset="-120"/>
               </a:rPr>
-              <a:t>Azure Container Registry (image pull)</a:t>
-            </a:r>
-            <a:endParaRPr lang="en-US" sz="1200" dirty="0"/>
+              <a:t>Azure Container Registry (image pull via managed identity)</a:t>
+            </a:r>
+            <a:endParaRPr lang="en-US" sz="1000" dirty="0"/>
           </a:p>
           <a:p>
             <a:pPr marL="342900" indent="-342900">
@@ -3092,7 +3255,7 @@
               <a:buChar char="•"/>
             </a:pPr>
             <a:r>
-              <a:rPr lang="en-US" sz="1200" dirty="0">
+              <a:rPr lang="en-US" sz="1000" dirty="0">
                 <a:solidFill>
                   <a:srgbClr val="EAF4F4"/>
                 </a:solidFill>
@@ -3100,9 +3263,9 @@
                 <a:ea typeface="Calibri" pitchFamily="34" charset="-122"/>
                 <a:cs typeface="Calibri" pitchFamily="34" charset="-120"/>
               </a:rPr>
-              <a:t>Azure Table Storage (leaderboard)</a:t>
-            </a:r>
-            <a:endParaRPr lang="en-US" sz="1200" dirty="0"/>
+              <a:t>Azure Table Storage (leaderboard, Azure AD auth only)</a:t>
+            </a:r>
+            <a:endParaRPr lang="en-US" sz="1000" dirty="0"/>
           </a:p>
           <a:p>
             <a:pPr marL="342900" indent="-342900">
@@ -3110,7 +3273,7 @@
               <a:buChar char="•"/>
             </a:pPr>
             <a:r>
-              <a:rPr lang="en-US" sz="1200" dirty="0">
+              <a:rPr lang="en-US" sz="1000" dirty="0">
                 <a:solidFill>
                   <a:srgbClr val="EAF4F4"/>
                 </a:solidFill>
@@ -3120,36 +3283,36 @@
               </a:rPr>
               <a:t>Log Analytics workspace (logs)</a:t>
             </a:r>
-            <a:endParaRPr lang="en-US" sz="1200" dirty="0"/>
-          </a:p>
-        </p:txBody>
-      </p:sp>
-      <p:sp>
-        <p:nvSpPr>
-          <p:cNvPr id="13" name="Text 11"/>
-          <p:cNvSpPr/>
-          <p:nvPr/>
-        </p:nvSpPr>
-        <p:spPr>
-          <a:xfrm>
-            <a:off x="5486400" y="2898648"/>
-            <a:ext cx="1188720" cy="228600"/>
-          </a:xfrm>
-          <a:prstGeom prst="rect">
-            <a:avLst/>
-          </a:prstGeom>
-          <a:noFill/>
-          <a:ln/>
-        </p:spPr>
-        <p:txBody>
-          <a:bodyPr wrap="square" lIns="0" tIns="0" rIns="0" bIns="0" rtlCol="0" anchor="ctr"/>
-          <a:lstStyle/>
-          <a:p>
-            <a:pPr algn="ctr" indent="0" marL="0">
-              <a:buNone/>
-            </a:pPr>
-            <a:r>
-              <a:rPr lang="en-US" sz="1100" dirty="0">
+            <a:endParaRPr lang="en-US" sz="1000" dirty="0"/>
+          </a:p>
+        </p:txBody>
+      </p:sp>
+      <p:sp>
+        <p:nvSpPr>
+          <p:cNvPr id="16" name="Text 14"/>
+          <p:cNvSpPr/>
+          <p:nvPr/>
+        </p:nvSpPr>
+        <p:spPr>
+          <a:xfrm>
+            <a:off x="548640" y="6382512"/>
+            <a:ext cx="11064240" cy="384048"/>
+          </a:xfrm>
+          <a:prstGeom prst="rect">
+            <a:avLst/>
+          </a:prstGeom>
+          <a:noFill/>
+          <a:ln/>
+        </p:spPr>
+        <p:txBody>
+          <a:bodyPr wrap="square" lIns="0" tIns="0" rIns="0" bIns="0" rtlCol="0" anchor="ctr"/>
+          <a:lstStyle/>
+          <a:p>
+            <a:pPr indent="0" marL="0">
+              <a:buNone/>
+            </a:pPr>
+            <a:r>
+              <a:rPr lang="en-US" sz="1050" i="1" dirty="0">
                 <a:solidFill>
                   <a:srgbClr val="3A3A3A"/>
                 </a:solidFill>
@@ -3157,87 +3320,9 @@
                 <a:ea typeface="Calibri" pitchFamily="34" charset="-122"/>
                 <a:cs typeface="Calibri" pitchFamily="34" charset="-120"/>
               </a:rPr>
-              <a:t>HTTPS ↓</a:t>
-            </a:r>
-            <a:endParaRPr lang="en-US" sz="1100" dirty="0"/>
-          </a:p>
-        </p:txBody>
-      </p:sp>
-      <p:sp>
-        <p:nvSpPr>
-          <p:cNvPr id="14" name="Text 12"/>
-          <p:cNvSpPr/>
-          <p:nvPr/>
-        </p:nvSpPr>
-        <p:spPr>
-          <a:xfrm>
-            <a:off x="4206240" y="4544568"/>
-            <a:ext cx="3657600" cy="228600"/>
-          </a:xfrm>
-          <a:prstGeom prst="rect">
-            <a:avLst/>
-          </a:prstGeom>
-          <a:noFill/>
-          <a:ln/>
-        </p:spPr>
-        <p:txBody>
-          <a:bodyPr wrap="square" lIns="0" tIns="0" rIns="0" bIns="0" rtlCol="0" anchor="ctr"/>
-          <a:lstStyle/>
-          <a:p>
-            <a:pPr algn="ctr" indent="0" marL="0">
-              <a:buNone/>
-            </a:pPr>
-            <a:r>
-              <a:rPr lang="en-US" sz="1100" dirty="0">
-                <a:solidFill>
-                  <a:srgbClr val="3A3A3A"/>
-                </a:solidFill>
-                <a:latin typeface="Calibri" pitchFamily="34" charset="0"/>
-                <a:ea typeface="Calibri" pitchFamily="34" charset="-122"/>
-                <a:cs typeface="Calibri" pitchFamily="34" charset="-120"/>
-              </a:rPr>
-              <a:t>OIDC-authenticated pulls / SDK calls ↓</a:t>
-            </a:r>
-            <a:endParaRPr lang="en-US" sz="1100" dirty="0"/>
-          </a:p>
-        </p:txBody>
-      </p:sp>
-      <p:sp>
-        <p:nvSpPr>
-          <p:cNvPr id="15" name="Text 13"/>
-          <p:cNvSpPr/>
-          <p:nvPr/>
-        </p:nvSpPr>
-        <p:spPr>
-          <a:xfrm>
-            <a:off x="548640" y="6080760"/>
-            <a:ext cx="11064240" cy="548640"/>
-          </a:xfrm>
-          <a:prstGeom prst="rect">
-            <a:avLst/>
-          </a:prstGeom>
-          <a:noFill/>
-          <a:ln/>
-        </p:spPr>
-        <p:txBody>
-          <a:bodyPr wrap="square" lIns="0" tIns="0" rIns="0" bIns="0" rtlCol="0" anchor="ctr"/>
-          <a:lstStyle/>
-          <a:p>
-            <a:pPr indent="0" marL="0">
-              <a:buNone/>
-            </a:pPr>
-            <a:r>
-              <a:rPr lang="en-US" sz="1200" i="1" dirty="0">
-                <a:solidFill>
-                  <a:srgbClr val="3A3A3A"/>
-                </a:solidFill>
-                <a:latin typeface="Calibri" pitchFamily="34" charset="0"/>
-                <a:ea typeface="Calibri" pitchFamily="34" charset="-122"/>
-                <a:cs typeface="Calibri" pitchFamily="34" charset="-120"/>
-              </a:rPr>
-              <a:t>“Hardware” in this project is entirely virtualized: no physical/on-prem hardware is provisioned. Compute, network, and storage are Azure-managed services described on the next slides.</a:t>
-            </a:r>
-            <a:endParaRPr lang="en-US" sz="1200" dirty="0"/>
+              <a:t>This subscription enforces tenant-level governance policies (public network access + shared-key auth both disabled on storage accounts) — the private endpoint and managed-identity auth above satisfy those policies.</a:t>
+            </a:r>
+            <a:endParaRPr lang="en-US" sz="1050" dirty="0"/>
           </a:p>
         </p:txBody>
       </p:sp>
@@ -3435,7 +3520,7 @@
               <a:buNone/>
             </a:pPr>
             <a:r>
-              <a:rPr lang="en-US" sz="1200" dirty="0">
+              <a:rPr lang="en-US" sz="1150" dirty="0">
                 <a:solidFill>
                   <a:srgbClr val="3A3A3A"/>
                 </a:solidFill>
@@ -3445,7 +3530,7 @@
               </a:rPr>
               <a:t>Next.js 16 (App Router), React 19, JavaScript (no TypeScript)</a:t>
             </a:r>
-            <a:endParaRPr lang="en-US" sz="1200" dirty="0"/>
+            <a:endParaRPr lang="en-US" sz="1150" dirty="0"/>
           </a:p>
         </p:txBody>
       </p:sp>
@@ -3513,7 +3598,7 @@
               <a:buNone/>
             </a:pPr>
             <a:r>
-              <a:rPr lang="en-US" sz="1200" dirty="0">
+              <a:rPr lang="en-US" sz="1150" dirty="0">
                 <a:solidFill>
                   <a:srgbClr val="3A3A3A"/>
                 </a:solidFill>
@@ -3523,7 +3608,7 @@
               </a:rPr>
               <a:t>Hand-rolled HTML5 Canvas game loop (requestAnimationFrame) — no game engine, per ADR-0001</a:t>
             </a:r>
-            <a:endParaRPr lang="en-US" sz="1200" dirty="0"/>
+            <a:endParaRPr lang="en-US" sz="1150" dirty="0"/>
           </a:p>
         </p:txBody>
       </p:sp>
@@ -3611,7 +3696,7 @@
               <a:buNone/>
             </a:pPr>
             <a:r>
-              <a:rPr lang="en-US" sz="1200" dirty="0">
+              <a:rPr lang="en-US" sz="1150" dirty="0">
                 <a:solidFill>
                   <a:srgbClr val="3A3A3A"/>
                 </a:solidFill>
@@ -3621,7 +3706,7 @@
               </a:rPr>
               <a:t>Web Audio API oscillator synthesis (square/triangle/sawtooth) — no external audio files</a:t>
             </a:r>
-            <a:endParaRPr lang="en-US" sz="1200" dirty="0"/>
+            <a:endParaRPr lang="en-US" sz="1150" dirty="0"/>
           </a:p>
         </p:txBody>
       </p:sp>
@@ -3689,7 +3774,7 @@
               <a:buNone/>
             </a:pPr>
             <a:r>
-              <a:rPr lang="en-US" sz="1200" dirty="0">
+              <a:rPr lang="en-US" sz="1150" dirty="0">
                 <a:solidFill>
                   <a:srgbClr val="3A3A3A"/>
                 </a:solidFill>
@@ -3697,9 +3782,9 @@
                 <a:ea typeface="Calibri" pitchFamily="34" charset="-122"/>
                 <a:cs typeface="Calibri" pitchFamily="34" charset="-120"/>
               </a:rPr>
-              <a:t>Azure Table Storage via @azure/data-tables SDK, abstracted behind a swappable storage client</a:t>
-            </a:r>
-            <a:endParaRPr lang="en-US" sz="1200" dirty="0"/>
+              <a:t>Azure Table Storage via @azure/data-tables, Azure AD auth via @azure/identity (DefaultAzureCredential)</a:t>
+            </a:r>
+            <a:endParaRPr lang="en-US" sz="1150" dirty="0"/>
           </a:p>
         </p:txBody>
       </p:sp>
@@ -3787,7 +3872,7 @@
               <a:buNone/>
             </a:pPr>
             <a:r>
-              <a:rPr lang="en-US" sz="1200" dirty="0">
+              <a:rPr lang="en-US" sz="1150" dirty="0">
                 <a:solidFill>
                   <a:srgbClr val="3A3A3A"/>
                 </a:solidFill>
@@ -3797,7 +3882,7 @@
               </a:rPr>
               <a:t>Vitest + Testing Library — 40 unit tests across 3 suites</a:t>
             </a:r>
-            <a:endParaRPr lang="en-US" sz="1200" dirty="0"/>
+            <a:endParaRPr lang="en-US" sz="1150" dirty="0"/>
           </a:p>
         </p:txBody>
       </p:sp>
@@ -3865,7 +3950,7 @@
               <a:buNone/>
             </a:pPr>
             <a:r>
-              <a:rPr lang="en-US" sz="1200" dirty="0">
+              <a:rPr lang="en-US" sz="1150" dirty="0">
                 <a:solidFill>
                   <a:srgbClr val="3A3A3A"/>
                 </a:solidFill>
@@ -3875,7 +3960,7 @@
               </a:rPr>
               <a:t>ESLint 9 (flat config) via eslint-config-next</a:t>
             </a:r>
-            <a:endParaRPr lang="en-US" sz="1200" dirty="0"/>
+            <a:endParaRPr lang="en-US" sz="1150" dirty="0"/>
           </a:p>
         </p:txBody>
       </p:sp>
@@ -3963,7 +4048,7 @@
               <a:buNone/>
             </a:pPr>
             <a:r>
-              <a:rPr lang="en-US" sz="1200" dirty="0">
+              <a:rPr lang="en-US" sz="1150" dirty="0">
                 <a:solidFill>
                   <a:srgbClr val="3A3A3A"/>
                 </a:solidFill>
@@ -3971,9 +4056,9 @@
                 <a:ea typeface="Calibri" pitchFamily="34" charset="-122"/>
                 <a:cs typeface="Calibri" pitchFamily="34" charset="-120"/>
               </a:rPr>
-              <a:t>Docker multi-stage build (deps → builder → runner), node:20-alpine, non-root user</a:t>
-            </a:r>
-            <a:endParaRPr lang="en-US" sz="1200" dirty="0"/>
+              <a:t>Docker multi-stage build (deps → builder → runner), node:20-alpine, non-root user, 286MB</a:t>
+            </a:r>
+            <a:endParaRPr lang="en-US" sz="1150" dirty="0"/>
           </a:p>
         </p:txBody>
       </p:sp>
@@ -4041,7 +4126,7 @@
               <a:buNone/>
             </a:pPr>
             <a:r>
-              <a:rPr lang="en-US" sz="1200" dirty="0">
+              <a:rPr lang="en-US" sz="1150" dirty="0">
                 <a:solidFill>
                   <a:srgbClr val="3A3A3A"/>
                 </a:solidFill>
@@ -4049,9 +4134,9 @@
                 <a:ea typeface="Calibri" pitchFamily="34" charset="-122"/>
                 <a:cs typeface="Calibri" pitchFamily="34" charset="-120"/>
               </a:rPr>
-              <a:t>Bicep, orchestrated by Azure Developer CLI (azd) — ADR-0003</a:t>
-            </a:r>
-            <a:endParaRPr lang="en-US" sz="1200" dirty="0"/>
+              <a:t>Bicep, orchestrated by Azure Developer CLI (azd) — ADR-0003, now includes VNet + private endpoint</a:t>
+            </a:r>
+            <a:endParaRPr lang="en-US" sz="1150" dirty="0"/>
           </a:p>
         </p:txBody>
       </p:sp>
@@ -4139,7 +4224,7 @@
               <a:buNone/>
             </a:pPr>
             <a:r>
-              <a:rPr lang="en-US" sz="1200" dirty="0">
+              <a:rPr lang="en-US" sz="1150" dirty="0">
                 <a:solidFill>
                   <a:srgbClr val="3A3A3A"/>
                 </a:solidFill>
@@ -4147,9 +4232,9 @@
                 <a:ea typeface="Calibri" pitchFamily="34" charset="-122"/>
                 <a:cs typeface="Calibri" pitchFamily="34" charset="-120"/>
               </a:rPr>
-              <a:t>GitHub Actions, OIDC federated credentials (no stored secrets)</a:t>
-            </a:r>
-            <a:endParaRPr lang="en-US" sz="1200" dirty="0"/>
+              <a:t>GitHub Actions: build/deploy on push to main (OIDC), plus a separate production smoke test workflow</a:t>
+            </a:r>
+            <a:endParaRPr lang="en-US" sz="1150" dirty="0"/>
           </a:p>
         </p:txBody>
       </p:sp>
@@ -4375,7 +4460,7 @@
               <a:buChar char="•"/>
             </a:pPr>
             <a:r>
-              <a:rPr lang="en-US" sz="1100" dirty="0">
+              <a:rPr lang="en-US" sz="1050" dirty="0">
                 <a:solidFill>
                   <a:srgbClr val="3A3A3A"/>
                 </a:solidFill>
@@ -4385,7 +4470,7 @@
               </a:rPr>
               <a:t>gameState.js — pure update(state,input,dt); movement, jump, climb, enemy AI, collision, lives, scoring</a:t>
             </a:r>
-            <a:endParaRPr lang="en-US" sz="1100" dirty="0"/>
+            <a:endParaRPr lang="en-US" sz="1050" dirty="0"/>
           </a:p>
           <a:p>
             <a:pPr marL="342900" indent="-342900">
@@ -4393,7 +4478,7 @@
               <a:buChar char="•"/>
             </a:pPr>
             <a:r>
-              <a:rPr lang="en-US" sz="1100" dirty="0">
+              <a:rPr lang="en-US" sz="1050" dirty="0">
                 <a:solidFill>
                   <a:srgbClr val="3A3A3A"/>
                 </a:solidFill>
@@ -4403,7 +4488,7 @@
               </a:rPr>
               <a:t>No DOM/Canvas dependency — the core unit-testing seam</a:t>
             </a:r>
-            <a:endParaRPr lang="en-US" sz="1100" dirty="0"/>
+            <a:endParaRPr lang="en-US" sz="1050" dirty="0"/>
           </a:p>
         </p:txBody>
       </p:sp>
@@ -4519,7 +4604,7 @@
               <a:buChar char="•"/>
             </a:pPr>
             <a:r>
-              <a:rPr lang="en-US" sz="1100" dirty="0">
+              <a:rPr lang="en-US" sz="1050" dirty="0">
                 <a:solidFill>
                   <a:srgbClr val="3A3A3A"/>
                 </a:solidFill>
@@ -4527,9 +4612,9 @@
                 <a:ea typeface="Calibri" pitchFamily="34" charset="-122"/>
                 <a:cs typeface="Calibri" pitchFamily="34" charset="-120"/>
               </a:rPr>
-              <a:t>scoresStorage.js — in-memory + Azure Table Storage client, auto-selected by env</a:t>
-            </a:r>
-            <a:endParaRPr lang="en-US" sz="1100" dirty="0"/>
+              <a:t>scoresStorage.js — in-memory + Azure Table Storage (Azure AD auth), auto-selected by env</a:t>
+            </a:r>
+            <a:endParaRPr lang="en-US" sz="1050" dirty="0"/>
           </a:p>
           <a:p>
             <a:pPr marL="342900" indent="-342900">
@@ -4537,7 +4622,7 @@
               <a:buChar char="•"/>
             </a:pPr>
             <a:r>
-              <a:rPr lang="en-US" sz="1100" dirty="0">
+              <a:rPr lang="en-US" sz="1050" dirty="0">
                 <a:solidFill>
                   <a:srgbClr val="3A3A3A"/>
                 </a:solidFill>
@@ -4547,7 +4632,7 @@
               </a:rPr>
               <a:t>sessionTokens.js — single-use tokens, rate limiting, score validation</a:t>
             </a:r>
-            <a:endParaRPr lang="en-US" sz="1100" dirty="0"/>
+            <a:endParaRPr lang="en-US" sz="1050" dirty="0"/>
           </a:p>
           <a:p>
             <a:pPr marL="342900" indent="-342900">
@@ -4555,7 +4640,7 @@
               <a:buChar char="•"/>
             </a:pPr>
             <a:r>
-              <a:rPr lang="en-US" sz="1100" dirty="0">
+              <a:rPr lang="en-US" sz="1050" dirty="0">
                 <a:solidFill>
                   <a:srgbClr val="3A3A3A"/>
                 </a:solidFill>
@@ -4565,7 +4650,7 @@
               </a:rPr>
               <a:t>api/scores/route.js — POST submit / GET top-N</a:t>
             </a:r>
-            <a:endParaRPr lang="en-US" sz="1100" dirty="0"/>
+            <a:endParaRPr lang="en-US" sz="1050" dirty="0"/>
           </a:p>
           <a:p>
             <a:pPr marL="342900" indent="-342900">
@@ -4573,7 +4658,7 @@
               <a:buChar char="•"/>
             </a:pPr>
             <a:r>
-              <a:rPr lang="en-US" sz="1100" dirty="0">
+              <a:rPr lang="en-US" sz="1050" dirty="0">
                 <a:solidFill>
                   <a:srgbClr val="3A3A3A"/>
                 </a:solidFill>
@@ -4583,7 +4668,7 @@
               </a:rPr>
               <a:t>api/session/route.js — issues play-session tokens</a:t>
             </a:r>
-            <a:endParaRPr lang="en-US" sz="1100" dirty="0"/>
+            <a:endParaRPr lang="en-US" sz="1050" dirty="0"/>
           </a:p>
         </p:txBody>
       </p:sp>
@@ -4699,7 +4784,7 @@
               <a:buChar char="•"/>
             </a:pPr>
             <a:r>
-              <a:rPr lang="en-US" sz="1100" dirty="0">
+              <a:rPr lang="en-US" sz="1050" dirty="0">
                 <a:solidFill>
                   <a:srgbClr val="3A3A3A"/>
                 </a:solidFill>
@@ -4707,9 +4792,9 @@
                 <a:ea typeface="Calibri" pitchFamily="34" charset="-122"/>
                 <a:cs typeface="Calibri" pitchFamily="34" charset="-120"/>
               </a:rPr>
-              <a:t>play/page.jsx — Canvas render loop, input handling, audio synthesis, HUD</a:t>
-            </a:r>
-            <a:endParaRPr lang="en-US" sz="1100" dirty="0"/>
+              <a:t>page.jsx — redirects "/" to "/play" (fixed after launch: root was blank)</a:t>
+            </a:r>
+            <a:endParaRPr lang="en-US" sz="1050" dirty="0"/>
           </a:p>
           <a:p>
             <a:pPr marL="342900" indent="-342900">
@@ -4717,7 +4802,7 @@
               <a:buChar char="•"/>
             </a:pPr>
             <a:r>
-              <a:rPr lang="en-US" sz="1100" dirty="0">
+              <a:rPr lang="en-US" sz="1050" dirty="0">
                 <a:solidFill>
                   <a:srgbClr val="3A3A3A"/>
                 </a:solidFill>
@@ -4725,9 +4810,9 @@
                 <a:ea typeface="Calibri" pitchFamily="34" charset="-122"/>
                 <a:cs typeface="Calibri" pitchFamily="34" charset="-120"/>
               </a:rPr>
-              <a:t>play/LeaderboardOverlay.jsx — game-over name entry + leaderboard display</a:t>
-            </a:r>
-            <a:endParaRPr lang="en-US" sz="1100" dirty="0"/>
+              <a:t>play/page.jsx — Canvas render loop, input handling, audio synthesis, HUD</a:t>
+            </a:r>
+            <a:endParaRPr lang="en-US" sz="1050" dirty="0"/>
           </a:p>
           <a:p>
             <a:pPr marL="342900" indent="-342900">
@@ -4735,7 +4820,7 @@
               <a:buChar char="•"/>
             </a:pPr>
             <a:r>
-              <a:rPr lang="en-US" sz="1100" dirty="0">
+              <a:rPr lang="en-US" sz="1050" dirty="0">
                 <a:solidFill>
                   <a:srgbClr val="3A3A3A"/>
                 </a:solidFill>
@@ -4743,9 +4828,27 @@
                 <a:ea typeface="Calibri" pitchFamily="34" charset="-122"/>
                 <a:cs typeface="Calibri" pitchFamily="34" charset="-120"/>
               </a:rPr>
-              <a:t>layout.jsx / page.jsx — root shell and landing route</a:t>
-            </a:r>
-            <a:endParaRPr lang="en-US" sz="1100" dirty="0"/>
+              <a:t>play/LeaderboardOverlay.jsx — game-over name entry + leaderboard display</a:t>
+            </a:r>
+            <a:endParaRPr lang="en-US" sz="1050" dirty="0"/>
+          </a:p>
+          <a:p>
+            <a:pPr marL="342900" indent="-342900">
+              <a:buSzPct val="100000"/>
+              <a:buChar char="•"/>
+            </a:pPr>
+            <a:r>
+              <a:rPr lang="en-US" sz="1050" dirty="0">
+                <a:solidFill>
+                  <a:srgbClr val="3A3A3A"/>
+                </a:solidFill>
+                <a:latin typeface="Calibri" pitchFamily="34" charset="0"/>
+                <a:ea typeface="Calibri" pitchFamily="34" charset="-122"/>
+                <a:cs typeface="Calibri" pitchFamily="34" charset="-120"/>
+              </a:rPr>
+              <a:t>layout.jsx — root shell</a:t>
+            </a:r>
+            <a:endParaRPr lang="en-US" sz="1050" dirty="0"/>
           </a:p>
         </p:txBody>
       </p:sp>
@@ -4808,7 +4911,7 @@
             <a:r>
               <a:rPr lang="en-US" sz="2600" b="1" dirty="0">
                 <a:solidFill>
-                  <a:srgbClr val="21295C"/>
+                  <a:srgbClr val="FFFFFF"/>
                 </a:solidFill>
                 <a:latin typeface="Trebuchet MS" pitchFamily="34" charset="0"/>
                 <a:ea typeface="Trebuchet MS" pitchFamily="34" charset="-122"/>
@@ -4828,8 +4931,8 @@
         </p:nvSpPr>
         <p:spPr>
           <a:xfrm>
-            <a:off x="457200" y="320040"/>
-            <a:ext cx="11247120" cy="548640"/>
+            <a:off x="457200" y="868680"/>
+            <a:ext cx="11247120" cy="365760"/>
           </a:xfrm>
           <a:prstGeom prst="rect">
             <a:avLst/>
@@ -4845,7 +4948,66 @@
               <a:buNone/>
             </a:pPr>
             <a:r>
-              <a:rPr lang="en-US" sz="2600" b="1" dirty="0">
+              <a:rPr lang="en-US" sz="1300" i="1" dirty="0">
+                <a:solidFill>
+                  <a:srgbClr val="1C7293"/>
+                </a:solidFill>
+                <a:latin typeface="Calibri" pitchFamily="34" charset="0"/>
+                <a:ea typeface="Calibri" pitchFamily="34" charset="-122"/>
+                <a:cs typeface="Calibri" pitchFamily="34" charset="-120"/>
+              </a:rPr>
+              <a:t>Client render loop and server request flow</a:t>
+            </a:r>
+            <a:endParaRPr lang="en-US" sz="1300" dirty="0"/>
+          </a:p>
+        </p:txBody>
+      </p:sp>
+      <p:sp>
+        <p:nvSpPr>
+          <p:cNvPr id="4" name="Shape 2"/>
+          <p:cNvSpPr/>
+          <p:nvPr/>
+        </p:nvSpPr>
+        <p:spPr>
+          <a:xfrm>
+            <a:off x="457200" y="1463040"/>
+            <a:ext cx="5486400" cy="365760"/>
+          </a:xfrm>
+          <a:prstGeom prst="rect">
+            <a:avLst/>
+          </a:prstGeom>
+          <a:solidFill>
+            <a:srgbClr val="1C7293"/>
+          </a:solidFill>
+          <a:ln/>
+        </p:spPr>
+      </p:sp>
+      <p:sp>
+        <p:nvSpPr>
+          <p:cNvPr id="5" name="Text 3"/>
+          <p:cNvSpPr/>
+          <p:nvPr/>
+        </p:nvSpPr>
+        <p:spPr>
+          <a:xfrm>
+            <a:off x="457200" y="1463040"/>
+            <a:ext cx="5486400" cy="365760"/>
+          </a:xfrm>
+          <a:prstGeom prst="rect">
+            <a:avLst/>
+          </a:prstGeom>
+          <a:noFill/>
+          <a:ln/>
+        </p:spPr>
+        <p:txBody>
+          <a:bodyPr wrap="square" lIns="0" tIns="0" rIns="0" bIns="0" rtlCol="0" anchor="ctr"/>
+          <a:lstStyle/>
+          <a:p>
+            <a:pPr algn="ctr" indent="0" marL="0">
+              <a:buNone/>
+            </a:pPr>
+            <a:r>
+              <a:rPr lang="en-US" sz="1250" b="1" dirty="0">
                 <a:solidFill>
                   <a:srgbClr val="FFFFFF"/>
                 </a:solidFill>
@@ -4853,104 +5015,6 @@
                 <a:ea typeface="Trebuchet MS" pitchFamily="34" charset="-122"/>
                 <a:cs typeface="Trebuchet MS" pitchFamily="34" charset="-120"/>
               </a:rPr>
-              <a:t>FUNCTION / CALL GRAPH</a:t>
-            </a:r>
-            <a:endParaRPr lang="en-US" sz="2600" dirty="0"/>
-          </a:p>
-        </p:txBody>
-      </p:sp>
-      <p:sp>
-        <p:nvSpPr>
-          <p:cNvPr id="4" name="Text 2"/>
-          <p:cNvSpPr/>
-          <p:nvPr/>
-        </p:nvSpPr>
-        <p:spPr>
-          <a:xfrm>
-            <a:off x="457200" y="868680"/>
-            <a:ext cx="11247120" cy="365760"/>
-          </a:xfrm>
-          <a:prstGeom prst="rect">
-            <a:avLst/>
-          </a:prstGeom>
-          <a:noFill/>
-          <a:ln/>
-        </p:spPr>
-        <p:txBody>
-          <a:bodyPr wrap="square" lIns="0" tIns="0" rIns="0" bIns="0" rtlCol="0" anchor="ctr"/>
-          <a:lstStyle/>
-          <a:p>
-            <a:pPr indent="0" marL="0">
-              <a:buNone/>
-            </a:pPr>
-            <a:r>
-              <a:rPr lang="en-US" sz="1300" i="1" dirty="0">
-                <a:solidFill>
-                  <a:srgbClr val="1C7293"/>
-                </a:solidFill>
-                <a:latin typeface="Calibri" pitchFamily="34" charset="0"/>
-                <a:ea typeface="Calibri" pitchFamily="34" charset="-122"/>
-                <a:cs typeface="Calibri" pitchFamily="34" charset="-120"/>
-              </a:rPr>
-              <a:t>Client render loop and server request flow</a:t>
-            </a:r>
-            <a:endParaRPr lang="en-US" sz="1300" dirty="0"/>
-          </a:p>
-        </p:txBody>
-      </p:sp>
-      <p:sp>
-        <p:nvSpPr>
-          <p:cNvPr id="5" name="Shape 3"/>
-          <p:cNvSpPr/>
-          <p:nvPr/>
-        </p:nvSpPr>
-        <p:spPr>
-          <a:xfrm>
-            <a:off x="457200" y="1463040"/>
-            <a:ext cx="5486400" cy="365760"/>
-          </a:xfrm>
-          <a:prstGeom prst="rect">
-            <a:avLst/>
-          </a:prstGeom>
-          <a:solidFill>
-            <a:srgbClr val="1C7293"/>
-          </a:solidFill>
-          <a:ln/>
-        </p:spPr>
-      </p:sp>
-      <p:sp>
-        <p:nvSpPr>
-          <p:cNvPr id="6" name="Text 4"/>
-          <p:cNvSpPr/>
-          <p:nvPr/>
-        </p:nvSpPr>
-        <p:spPr>
-          <a:xfrm>
-            <a:off x="457200" y="1463040"/>
-            <a:ext cx="5486400" cy="365760"/>
-          </a:xfrm>
-          <a:prstGeom prst="rect">
-            <a:avLst/>
-          </a:prstGeom>
-          <a:noFill/>
-          <a:ln/>
-        </p:spPr>
-        <p:txBody>
-          <a:bodyPr wrap="square" lIns="0" tIns="0" rIns="0" bIns="0" rtlCol="0" anchor="ctr"/>
-          <a:lstStyle/>
-          <a:p>
-            <a:pPr algn="ctr" indent="0" marL="0">
-              <a:buNone/>
-            </a:pPr>
-            <a:r>
-              <a:rPr lang="en-US" sz="1250" b="1" dirty="0">
-                <a:solidFill>
-                  <a:srgbClr val="FFFFFF"/>
-                </a:solidFill>
-                <a:latin typeface="Trebuchet MS" pitchFamily="34" charset="0"/>
-                <a:ea typeface="Trebuchet MS" pitchFamily="34" charset="-122"/>
-                <a:cs typeface="Trebuchet MS" pitchFamily="34" charset="-120"/>
-              </a:rPr>
               <a:t>CLIENT RENDER LOOP  (app/play/page.jsx)</a:t>
             </a:r>
             <a:endParaRPr lang="en-US" sz="1250" dirty="0"/>
@@ -4959,7 +5023,7 @@
       </p:sp>
       <p:sp>
         <p:nvSpPr>
-          <p:cNvPr id="7" name="Shape 5"/>
+          <p:cNvPr id="6" name="Shape 4"/>
           <p:cNvSpPr/>
           <p:nvPr/>
         </p:nvSpPr>
@@ -4981,7 +5045,7 @@
       </p:sp>
       <p:sp>
         <p:nvSpPr>
-          <p:cNvPr id="8" name="Text 6"/>
+          <p:cNvPr id="7" name="Text 5"/>
           <p:cNvSpPr/>
           <p:nvPr/>
         </p:nvSpPr>
@@ -5020,7 +5084,7 @@
       </p:sp>
       <p:sp>
         <p:nvSpPr>
-          <p:cNvPr id="9" name="Text 7"/>
+          <p:cNvPr id="8" name="Text 6"/>
           <p:cNvSpPr/>
           <p:nvPr/>
         </p:nvSpPr>
@@ -5056,7 +5120,7 @@
       </p:sp>
       <p:sp>
         <p:nvSpPr>
-          <p:cNvPr id="10" name="Shape 8"/>
+          <p:cNvPr id="9" name="Shape 7"/>
           <p:cNvSpPr/>
           <p:nvPr/>
         </p:nvSpPr>
@@ -5078,7 +5142,7 @@
       </p:sp>
       <p:sp>
         <p:nvSpPr>
-          <p:cNvPr id="11" name="Text 9"/>
+          <p:cNvPr id="10" name="Text 8"/>
           <p:cNvSpPr/>
           <p:nvPr/>
         </p:nvSpPr>
@@ -5117,7 +5181,7 @@
       </p:sp>
       <p:sp>
         <p:nvSpPr>
-          <p:cNvPr id="12" name="Text 10"/>
+          <p:cNvPr id="11" name="Text 9"/>
           <p:cNvSpPr/>
           <p:nvPr/>
         </p:nvSpPr>
@@ -5153,7 +5217,7 @@
       </p:sp>
       <p:sp>
         <p:nvSpPr>
-          <p:cNvPr id="13" name="Shape 11"/>
+          <p:cNvPr id="12" name="Shape 10"/>
           <p:cNvSpPr/>
           <p:nvPr/>
         </p:nvSpPr>
@@ -5175,7 +5239,7 @@
       </p:sp>
       <p:sp>
         <p:nvSpPr>
-          <p:cNvPr id="14" name="Text 12"/>
+          <p:cNvPr id="13" name="Text 11"/>
           <p:cNvSpPr/>
           <p:nvPr/>
         </p:nvSpPr>
@@ -5214,7 +5278,7 @@
       </p:sp>
       <p:sp>
         <p:nvSpPr>
-          <p:cNvPr id="15" name="Text 13"/>
+          <p:cNvPr id="14" name="Text 12"/>
           <p:cNvSpPr/>
           <p:nvPr/>
         </p:nvSpPr>
@@ -5250,7 +5314,7 @@
       </p:sp>
       <p:sp>
         <p:nvSpPr>
-          <p:cNvPr id="16" name="Shape 14"/>
+          <p:cNvPr id="15" name="Shape 13"/>
           <p:cNvSpPr/>
           <p:nvPr/>
         </p:nvSpPr>
@@ -5272,7 +5336,7 @@
       </p:sp>
       <p:sp>
         <p:nvSpPr>
-          <p:cNvPr id="17" name="Text 15"/>
+          <p:cNvPr id="16" name="Text 14"/>
           <p:cNvSpPr/>
           <p:nvPr/>
         </p:nvSpPr>
@@ -5311,7 +5375,7 @@
       </p:sp>
       <p:sp>
         <p:nvSpPr>
-          <p:cNvPr id="18" name="Text 16"/>
+          <p:cNvPr id="17" name="Text 15"/>
           <p:cNvSpPr/>
           <p:nvPr/>
         </p:nvSpPr>
@@ -5347,7 +5411,7 @@
       </p:sp>
       <p:sp>
         <p:nvSpPr>
-          <p:cNvPr id="19" name="Shape 17"/>
+          <p:cNvPr id="18" name="Shape 16"/>
           <p:cNvSpPr/>
           <p:nvPr/>
         </p:nvSpPr>
@@ -5369,7 +5433,7 @@
       </p:sp>
       <p:sp>
         <p:nvSpPr>
-          <p:cNvPr id="20" name="Text 18"/>
+          <p:cNvPr id="19" name="Text 17"/>
           <p:cNvSpPr/>
           <p:nvPr/>
         </p:nvSpPr>
@@ -5408,7 +5472,7 @@
       </p:sp>
       <p:sp>
         <p:nvSpPr>
-          <p:cNvPr id="21" name="Shape 19"/>
+          <p:cNvPr id="20" name="Shape 18"/>
           <p:cNvSpPr/>
           <p:nvPr/>
         </p:nvSpPr>
@@ -5428,7 +5492,7 @@
       </p:sp>
       <p:sp>
         <p:nvSpPr>
-          <p:cNvPr id="22" name="Text 20"/>
+          <p:cNvPr id="21" name="Text 19"/>
           <p:cNvSpPr/>
           <p:nvPr/>
         </p:nvSpPr>
@@ -5467,7 +5531,7 @@
       </p:sp>
       <p:sp>
         <p:nvSpPr>
-          <p:cNvPr id="23" name="Shape 21"/>
+          <p:cNvPr id="22" name="Shape 20"/>
           <p:cNvSpPr/>
           <p:nvPr/>
         </p:nvSpPr>
@@ -5489,7 +5553,7 @@
       </p:sp>
       <p:sp>
         <p:nvSpPr>
-          <p:cNvPr id="24" name="Text 22"/>
+          <p:cNvPr id="23" name="Text 21"/>
           <p:cNvSpPr/>
           <p:nvPr/>
         </p:nvSpPr>
@@ -5528,7 +5592,7 @@
       </p:sp>
       <p:sp>
         <p:nvSpPr>
-          <p:cNvPr id="25" name="Text 23"/>
+          <p:cNvPr id="24" name="Text 22"/>
           <p:cNvSpPr/>
           <p:nvPr/>
         </p:nvSpPr>
@@ -5564,7 +5628,7 @@
       </p:sp>
       <p:sp>
         <p:nvSpPr>
-          <p:cNvPr id="26" name="Shape 24"/>
+          <p:cNvPr id="25" name="Shape 23"/>
           <p:cNvSpPr/>
           <p:nvPr/>
         </p:nvSpPr>
@@ -5586,7 +5650,7 @@
       </p:sp>
       <p:sp>
         <p:nvSpPr>
-          <p:cNvPr id="27" name="Text 25"/>
+          <p:cNvPr id="26" name="Text 24"/>
           <p:cNvSpPr/>
           <p:nvPr/>
         </p:nvSpPr>
@@ -5625,7 +5689,7 @@
       </p:sp>
       <p:sp>
         <p:nvSpPr>
-          <p:cNvPr id="28" name="Text 26"/>
+          <p:cNvPr id="27" name="Text 25"/>
           <p:cNvSpPr/>
           <p:nvPr/>
         </p:nvSpPr>
@@ -5661,7 +5725,7 @@
       </p:sp>
       <p:sp>
         <p:nvSpPr>
-          <p:cNvPr id="29" name="Shape 27"/>
+          <p:cNvPr id="28" name="Shape 26"/>
           <p:cNvSpPr/>
           <p:nvPr/>
         </p:nvSpPr>
@@ -5683,7 +5747,7 @@
       </p:sp>
       <p:sp>
         <p:nvSpPr>
-          <p:cNvPr id="30" name="Text 28"/>
+          <p:cNvPr id="29" name="Text 27"/>
           <p:cNvSpPr/>
           <p:nvPr/>
         </p:nvSpPr>
@@ -5722,7 +5786,7 @@
       </p:sp>
       <p:sp>
         <p:nvSpPr>
-          <p:cNvPr id="31" name="Text 29"/>
+          <p:cNvPr id="30" name="Text 28"/>
           <p:cNvSpPr/>
           <p:nvPr/>
         </p:nvSpPr>
@@ -5758,7 +5822,7 @@
       </p:sp>
       <p:sp>
         <p:nvSpPr>
-          <p:cNvPr id="32" name="Shape 30"/>
+          <p:cNvPr id="31" name="Shape 29"/>
           <p:cNvSpPr/>
           <p:nvPr/>
         </p:nvSpPr>
@@ -5780,7 +5844,7 @@
       </p:sp>
       <p:sp>
         <p:nvSpPr>
-          <p:cNvPr id="33" name="Text 31"/>
+          <p:cNvPr id="32" name="Text 30"/>
           <p:cNvSpPr/>
           <p:nvPr/>
         </p:nvSpPr>
@@ -5819,7 +5883,7 @@
       </p:sp>
       <p:sp>
         <p:nvSpPr>
-          <p:cNvPr id="34" name="Text 32"/>
+          <p:cNvPr id="33" name="Text 31"/>
           <p:cNvSpPr/>
           <p:nvPr/>
         </p:nvSpPr>
@@ -5855,7 +5919,7 @@
       </p:sp>
       <p:sp>
         <p:nvSpPr>
-          <p:cNvPr id="35" name="Shape 33"/>
+          <p:cNvPr id="34" name="Shape 32"/>
           <p:cNvSpPr/>
           <p:nvPr/>
         </p:nvSpPr>
@@ -5877,7 +5941,7 @@
       </p:sp>
       <p:sp>
         <p:nvSpPr>
-          <p:cNvPr id="36" name="Text 34"/>
+          <p:cNvPr id="35" name="Text 33"/>
           <p:cNvSpPr/>
           <p:nvPr/>
         </p:nvSpPr>
@@ -5916,7 +5980,7 @@
       </p:sp>
       <p:sp>
         <p:nvSpPr>
-          <p:cNvPr id="37" name="Text 35"/>
+          <p:cNvPr id="36" name="Text 34"/>
           <p:cNvSpPr/>
           <p:nvPr/>
         </p:nvSpPr>
@@ -5947,7 +6011,7 @@
                 <a:ea typeface="Calibri" pitchFamily="34" charset="-122"/>
                 <a:cs typeface="Calibri" pitchFamily="34" charset="-120"/>
               </a:rPr>
-              <a:t>getStorageClient() auto-selects: Azure Table Storage when AZURE_STORAGE_CONNECTION_STRING is set (production), otherwise an in-memory implementation (local dev &amp; tests).</a:t>
+              <a:t>getStorageClient() connects to Azure Table Storage via a private endpoint using DefaultAzureCredential (the Container App's user-assigned managed identity) — no connection string, no public network path.</a:t>
             </a:r>
             <a:endParaRPr lang="en-US" sz="1150" dirty="0"/>
           </a:p>
@@ -6252,7 +6316,7 @@
                 <a:ea typeface="Trebuchet MS" pitchFamily="34" charset="-122"/>
                 <a:cs typeface="Trebuchet MS" pitchFamily="34" charset="-120"/>
               </a:rPr>
-              <a:t>6</a:t>
+              <a:t>8</a:t>
             </a:r>
             <a:endParaRPr lang="en-US" sz="4400" dirty="0"/>
           </a:p>
@@ -6330,7 +6394,7 @@
                 <a:ea typeface="Trebuchet MS" pitchFamily="34" charset="-122"/>
                 <a:cs typeface="Trebuchet MS" pitchFamily="34" charset="-120"/>
               </a:rPr>
-              <a:t>6</a:t>
+              <a:t>7</a:t>
             </a:r>
             <a:endParaRPr lang="en-US" sz="4400" dirty="0"/>
           </a:p>
@@ -6386,7 +6450,7 @@
                 <a:ea typeface="Calibri" pitchFamily="34" charset="-122"/>
                 <a:cs typeface="Calibri" pitchFamily="34" charset="-120"/>
               </a:rPr>
-              <a:t>pre-merge</a:t>
+              <a:t>pre/post-merge</a:t>
             </a:r>
             <a:endParaRPr lang="en-US" sz="1200" dirty="0"/>
           </a:p>
@@ -6463,7 +6527,7 @@
         <p:spPr>
           <a:xfrm>
             <a:off x="548640" y="3931920"/>
-            <a:ext cx="1737360" cy="777240"/>
+            <a:ext cx="1490472" cy="777240"/>
           </a:xfrm>
           <a:prstGeom prst="roundRect">
             <a:avLst>
@@ -6485,7 +6549,7 @@
         <p:spPr>
           <a:xfrm>
             <a:off x="594360" y="3931920"/>
-            <a:ext cx="1645920" cy="777240"/>
+            <a:ext cx="1399032" cy="777240"/>
           </a:xfrm>
           <a:prstGeom prst="rect">
             <a:avLst/>
@@ -6501,7 +6565,7 @@
               <a:buNone/>
             </a:pPr>
             <a:r>
-              <a:rPr lang="en-US" sz="1000" dirty="0">
+              <a:rPr lang="en-US" sz="950" dirty="0">
                 <a:solidFill>
                   <a:srgbClr val="FFFFFF"/>
                 </a:solidFill>
@@ -6511,7 +6575,7 @@
               </a:rPr>
               <a:t>npm install</a:t>
             </a:r>
-            <a:endParaRPr lang="en-US" sz="1000" dirty="0"/>
+            <a:endParaRPr lang="en-US" sz="950" dirty="0"/>
           </a:p>
         </p:txBody>
       </p:sp>
@@ -6523,8 +6587,8 @@
         </p:nvSpPr>
         <p:spPr>
           <a:xfrm>
-            <a:off x="2331720" y="3931920"/>
-            <a:ext cx="1737360" cy="777240"/>
+            <a:off x="2084832" y="3931920"/>
+            <a:ext cx="1490472" cy="777240"/>
           </a:xfrm>
           <a:prstGeom prst="roundRect">
             <a:avLst>
@@ -6545,8 +6609,8 @@
         </p:nvSpPr>
         <p:spPr>
           <a:xfrm>
-            <a:off x="2377440" y="3931920"/>
-            <a:ext cx="1645920" cy="777240"/>
+            <a:off x="2130552" y="3931920"/>
+            <a:ext cx="1399032" cy="777240"/>
           </a:xfrm>
           <a:prstGeom prst="rect">
             <a:avLst/>
@@ -6562,7 +6626,7 @@
               <a:buNone/>
             </a:pPr>
             <a:r>
-              <a:rPr lang="en-US" sz="1000" dirty="0">
+              <a:rPr lang="en-US" sz="950" dirty="0">
                 <a:solidFill>
                   <a:srgbClr val="FFFFFF"/>
                 </a:solidFill>
@@ -6572,7 +6636,7 @@
               </a:rPr>
               <a:t>npm run lint</a:t>
             </a:r>
-            <a:endParaRPr lang="en-US" sz="1000" dirty="0"/>
+            <a:endParaRPr lang="en-US" sz="950" dirty="0"/>
           </a:p>
         </p:txBody>
       </p:sp>
@@ -6584,8 +6648,8 @@
         </p:nvSpPr>
         <p:spPr>
           <a:xfrm>
-            <a:off x="4114800" y="3931920"/>
-            <a:ext cx="1737360" cy="777240"/>
+            <a:off x="3621024" y="3931920"/>
+            <a:ext cx="1490472" cy="777240"/>
           </a:xfrm>
           <a:prstGeom prst="roundRect">
             <a:avLst>
@@ -6606,8 +6670,8 @@
         </p:nvSpPr>
         <p:spPr>
           <a:xfrm>
-            <a:off x="4160520" y="3931920"/>
-            <a:ext cx="1645920" cy="777240"/>
+            <a:off x="3666744" y="3931920"/>
+            <a:ext cx="1399032" cy="777240"/>
           </a:xfrm>
           <a:prstGeom prst="rect">
             <a:avLst/>
@@ -6623,7 +6687,7 @@
               <a:buNone/>
             </a:pPr>
             <a:r>
-              <a:rPr lang="en-US" sz="1000" dirty="0">
+              <a:rPr lang="en-US" sz="950" dirty="0">
                 <a:solidFill>
                   <a:srgbClr val="FFFFFF"/>
                 </a:solidFill>
@@ -6633,7 +6697,7 @@
               </a:rPr>
               <a:t>npx vitest run</a:t>
             </a:r>
-            <a:endParaRPr lang="en-US" sz="1000" dirty="0"/>
+            <a:endParaRPr lang="en-US" sz="950" dirty="0"/>
           </a:p>
         </p:txBody>
       </p:sp>
@@ -6645,8 +6709,8 @@
         </p:nvSpPr>
         <p:spPr>
           <a:xfrm>
-            <a:off x="5897880" y="3931920"/>
-            <a:ext cx="1737360" cy="777240"/>
+            <a:off x="5157216" y="3931920"/>
+            <a:ext cx="1490472" cy="777240"/>
           </a:xfrm>
           <a:prstGeom prst="roundRect">
             <a:avLst>
@@ -6667,8 +6731,8 @@
         </p:nvSpPr>
         <p:spPr>
           <a:xfrm>
-            <a:off x="5943600" y="3931920"/>
-            <a:ext cx="1645920" cy="777240"/>
+            <a:off x="5202936" y="3931920"/>
+            <a:ext cx="1399032" cy="777240"/>
           </a:xfrm>
           <a:prstGeom prst="rect">
             <a:avLst/>
@@ -6684,7 +6748,7 @@
               <a:buNone/>
             </a:pPr>
             <a:r>
-              <a:rPr lang="en-US" sz="1000" dirty="0">
+              <a:rPr lang="en-US" sz="950" dirty="0">
                 <a:solidFill>
                   <a:srgbClr val="FFFFFF"/>
                 </a:solidFill>
@@ -6694,7 +6758,7 @@
               </a:rPr>
               <a:t>npm run build</a:t>
             </a:r>
-            <a:endParaRPr lang="en-US" sz="1000" dirty="0"/>
+            <a:endParaRPr lang="en-US" sz="950" dirty="0"/>
           </a:p>
         </p:txBody>
       </p:sp>
@@ -6706,8 +6770,8 @@
         </p:nvSpPr>
         <p:spPr>
           <a:xfrm>
-            <a:off x="7680960" y="3931920"/>
-            <a:ext cx="1737360" cy="777240"/>
+            <a:off x="6693408" y="3931920"/>
+            <a:ext cx="1490472" cy="777240"/>
           </a:xfrm>
           <a:prstGeom prst="roundRect">
             <a:avLst>
@@ -6728,8 +6792,8 @@
         </p:nvSpPr>
         <p:spPr>
           <a:xfrm>
-            <a:off x="7726680" y="3931920"/>
-            <a:ext cx="1645920" cy="777240"/>
+            <a:off x="6739128" y="3931920"/>
+            <a:ext cx="1399032" cy="777240"/>
           </a:xfrm>
           <a:prstGeom prst="rect">
             <a:avLst/>
@@ -6745,7 +6809,7 @@
               <a:buNone/>
             </a:pPr>
             <a:r>
-              <a:rPr lang="en-US" sz="1000" dirty="0">
+              <a:rPr lang="en-US" sz="950" dirty="0">
                 <a:solidFill>
                   <a:srgbClr val="FFFFFF"/>
                 </a:solidFill>
@@ -6753,9 +6817,9 @@
                 <a:ea typeface="Calibri" pitchFamily="34" charset="-122"/>
                 <a:cs typeface="Calibri" pitchFamily="34" charset="-120"/>
               </a:rPr>
-              <a:t>rubber-duck logic review</a:t>
-            </a:r>
-            <a:endParaRPr lang="en-US" sz="1000" dirty="0"/>
+              <a:t>rubber-duck review</a:t>
+            </a:r>
+            <a:endParaRPr lang="en-US" sz="950" dirty="0"/>
           </a:p>
         </p:txBody>
       </p:sp>
@@ -6767,8 +6831,8 @@
         </p:nvSpPr>
         <p:spPr>
           <a:xfrm>
-            <a:off x="9464040" y="3931920"/>
-            <a:ext cx="1737360" cy="777240"/>
+            <a:off x="8229600" y="3931920"/>
+            <a:ext cx="1490472" cy="777240"/>
           </a:xfrm>
           <a:prstGeom prst="roundRect">
             <a:avLst>
@@ -6776,7 +6840,7 @@
             </a:avLst>
           </a:prstGeom>
           <a:solidFill>
-            <a:srgbClr val="F96167"/>
+            <a:srgbClr val="065A82"/>
           </a:solidFill>
           <a:ln/>
         </p:spPr>
@@ -6789,8 +6853,8 @@
         </p:nvSpPr>
         <p:spPr>
           <a:xfrm>
-            <a:off x="9509760" y="3931920"/>
-            <a:ext cx="1645920" cy="777240"/>
+            <a:off x="8275320" y="3931920"/>
+            <a:ext cx="1399032" cy="777240"/>
           </a:xfrm>
           <a:prstGeom prst="rect">
             <a:avLst/>
@@ -6806,7 +6870,7 @@
               <a:buNone/>
             </a:pPr>
             <a:r>
-              <a:rPr lang="en-US" sz="1000" dirty="0">
+              <a:rPr lang="en-US" sz="950" dirty="0">
                 <a:solidFill>
                   <a:srgbClr val="FFFFFF"/>
                 </a:solidFill>
@@ -6814,15 +6878,76 @@
                 <a:ea typeface="Calibri" pitchFamily="34" charset="-122"/>
                 <a:cs typeface="Calibri" pitchFamily="34" charset="-120"/>
               </a:rPr>
-              <a:t>merge only if clean</a:t>
-            </a:r>
-            <a:endParaRPr lang="en-US" sz="1000" dirty="0"/>
-          </a:p>
-        </p:txBody>
-      </p:sp>
-      <p:sp>
-        <p:nvSpPr>
-          <p:cNvPr id="26" name="Text 24"/>
+              <a:t>docker/curl verify</a:t>
+            </a:r>
+            <a:endParaRPr lang="en-US" sz="950" dirty="0"/>
+          </a:p>
+        </p:txBody>
+      </p:sp>
+      <p:sp>
+        <p:nvSpPr>
+          <p:cNvPr id="26" name="Shape 24"/>
+          <p:cNvSpPr/>
+          <p:nvPr/>
+        </p:nvSpPr>
+        <p:spPr>
+          <a:xfrm>
+            <a:off x="9765792" y="3931920"/>
+            <a:ext cx="1490472" cy="777240"/>
+          </a:xfrm>
+          <a:prstGeom prst="roundRect">
+            <a:avLst>
+              <a:gd name="adj" fmla="val 9412"/>
+            </a:avLst>
+          </a:prstGeom>
+          <a:solidFill>
+            <a:srgbClr val="F96167"/>
+          </a:solidFill>
+          <a:ln/>
+        </p:spPr>
+      </p:sp>
+      <p:sp>
+        <p:nvSpPr>
+          <p:cNvPr id="27" name="Text 25"/>
+          <p:cNvSpPr/>
+          <p:nvPr/>
+        </p:nvSpPr>
+        <p:spPr>
+          <a:xfrm>
+            <a:off x="9811512" y="3931920"/>
+            <a:ext cx="1399032" cy="777240"/>
+          </a:xfrm>
+          <a:prstGeom prst="rect">
+            <a:avLst/>
+          </a:prstGeom>
+          <a:noFill/>
+          <a:ln/>
+        </p:spPr>
+        <p:txBody>
+          <a:bodyPr wrap="square" lIns="0" tIns="0" rIns="0" bIns="0" rtlCol="0" anchor="ctr"/>
+          <a:lstStyle/>
+          <a:p>
+            <a:pPr algn="ctr" indent="0" marL="0">
+              <a:buNone/>
+            </a:pPr>
+            <a:r>
+              <a:rPr lang="en-US" sz="950" dirty="0">
+                <a:solidFill>
+                  <a:srgbClr val="FFFFFF"/>
+                </a:solidFill>
+                <a:latin typeface="Calibri" pitchFamily="34" charset="0"/>
+                <a:ea typeface="Calibri" pitchFamily="34" charset="-122"/>
+                <a:cs typeface="Calibri" pitchFamily="34" charset="-120"/>
+              </a:rPr>
+              <a:t>merge if clean</a:t>
+            </a:r>
+            <a:endParaRPr lang="en-US" sz="950" dirty="0"/>
+          </a:p>
+        </p:txBody>
+      </p:sp>
+      <p:sp>
+        <p:nvSpPr>
+          <p:cNvPr id="28" name="Text 26"/>
           <p:cNvSpPr/>
           <p:nvPr/>
         </p:nvSpPr>
@@ -6853,7 +6978,7 @@
                 <a:ea typeface="Trebuchet MS" pitchFamily="34" charset="-122"/>
                 <a:cs typeface="Trebuchet MS" pitchFamily="34" charset="-120"/>
               </a:rPr>
-              <a:t>Bugs caught before merge (examples):</a:t>
+              <a:t>Bugs caught this way (examples):</a:t>
             </a:r>
             <a:endParaRPr lang="en-US" sz="1500" dirty="0"/>
           </a:p>
@@ -6861,7 +6986,7 @@
       </p:sp>
       <p:sp>
         <p:nvSpPr>
-          <p:cNvPr id="27" name="Text 25"/>
+          <p:cNvPr id="29" name="Text 27"/>
           <p:cNvSpPr/>
           <p:nvPr/>
         </p:nvSpPr>
@@ -6885,7 +7010,7 @@
               <a:buChar char="•"/>
             </a:pPr>
             <a:r>
-              <a:rPr lang="en-US" sz="1150" dirty="0">
+              <a:rPr lang="en-US" sz="1100" dirty="0">
                 <a:solidFill>
                   <a:srgbClr val="3A3A3A"/>
                 </a:solidFill>
@@ -6893,9 +7018,9 @@
                 <a:ea typeface="Calibri" pitchFamily="34" charset="-122"/>
                 <a:cs typeface="Calibri" pitchFamily="34" charset="-120"/>
               </a:rPr>
-              <a:t>Duplicate render loop when the player sprite image was already cached</a:t>
-            </a:r>
-            <a:endParaRPr lang="en-US" sz="1150" dirty="0"/>
+              <a:t>Duplicate render loop on cached sprites; climbing-disables-gravity physics bug</a:t>
+            </a:r>
+            <a:endParaRPr lang="en-US" sz="1100" dirty="0"/>
           </a:p>
           <a:p>
             <a:pPr marL="342900" indent="-342900">
@@ -6903,7 +7028,7 @@
               <a:buChar char="•"/>
             </a:pPr>
             <a:r>
-              <a:rPr lang="en-US" sz="1150" dirty="0">
+              <a:rPr lang="en-US" sz="1100" dirty="0">
                 <a:solidFill>
                   <a:srgbClr val="3A3A3A"/>
                 </a:solidFill>
@@ -6911,9 +7036,9 @@
                 <a:ea typeface="Calibri" pitchFamily="34" charset="-122"/>
                 <a:cs typeface="Calibri" pitchFamily="34" charset="-120"/>
               </a:rPr>
-              <a:t>Climbing left onGround=true, so gravity never re-engaged (player could float)</a:t>
-            </a:r>
-            <a:endParaRPr lang="en-US" sz="1150" dirty="0"/>
+              <a:t>Final life-loss SFX silently suppressed by an else-if branch</a:t>
+            </a:r>
+            <a:endParaRPr lang="en-US" sz="1100" dirty="0"/>
           </a:p>
           <a:p>
             <a:pPr marL="342900" indent="-342900">
@@ -6921,7 +7046,7 @@
               <a:buChar char="•"/>
             </a:pPr>
             <a:r>
-              <a:rPr lang="en-US" sz="1150" dirty="0">
+              <a:rPr lang="en-US" sz="1100" dirty="0">
                 <a:solidFill>
                   <a:srgbClr val="3A3A3A"/>
                 </a:solidFill>
@@ -6929,9 +7054,9 @@
                 <a:ea typeface="Calibri" pitchFamily="34" charset="-122"/>
                 <a:cs typeface="Calibri" pitchFamily="34" charset="-120"/>
               </a:rPr>
-              <a:t>Final life-loss SFX silently suppressed by an else-if branch</a:t>
-            </a:r>
-            <a:endParaRPr lang="en-US" sz="1150" dirty="0"/>
+              <a:t>@azure/data-tables used but never declared as a real dependency</a:t>
+            </a:r>
+            <a:endParaRPr lang="en-US" sz="1100" dirty="0"/>
           </a:p>
           <a:p>
             <a:pPr marL="342900" indent="-342900">
@@ -6939,7 +7064,7 @@
               <a:buChar char="•"/>
             </a:pPr>
             <a:r>
-              <a:rPr lang="en-US" sz="1150" dirty="0">
+              <a:rPr lang="en-US" sz="1100" dirty="0">
                 <a:solidFill>
                   <a:srgbClr val="3A3A3A"/>
                 </a:solidFill>
@@ -6947,9 +7072,9 @@
                 <a:ea typeface="Calibri" pitchFamily="34" charset="-122"/>
                 <a:cs typeface="Calibri" pitchFamily="34" charset="-120"/>
               </a:rPr>
-              <a:t>@azure/data-tables used but never declared as a real dependency</a:t>
-            </a:r>
-            <a:endParaRPr lang="en-US" sz="1150" dirty="0"/>
+              <a:t>Docker image 3× larger than necessary; smoke-test script validated the wrong JSON shape</a:t>
+            </a:r>
+            <a:endParaRPr lang="en-US" sz="1100" dirty="0"/>
           </a:p>
           <a:p>
             <a:pPr marL="342900" indent="-342900">
@@ -6957,7 +7082,7 @@
               <a:buChar char="•"/>
             </a:pPr>
             <a:r>
-              <a:rPr lang="en-US" sz="1150" dirty="0">
+              <a:rPr lang="en-US" sz="1100" dirty="0">
                 <a:solidFill>
                   <a:srgbClr val="3A3A3A"/>
                 </a:solidFill>
@@ -6965,9 +7090,9 @@
                 <a:ea typeface="Calibri" pitchFamily="34" charset="-122"/>
                 <a:cs typeface="Calibri" pitchFamily="34" charset="-120"/>
               </a:rPr>
-              <a:t>Docker image 3× larger than necessary from a redundant dependency install</a:t>
-            </a:r>
-            <a:endParaRPr lang="en-US" sz="1150" dirty="0"/>
+              <a:t>Post-launch: root route ("/") left blank — fixed with a redirect to /play</a:t>
+            </a:r>
+            <a:endParaRPr lang="en-US" sz="1100" dirty="0"/>
           </a:p>
         </p:txBody>
       </p:sp>
@@ -7089,7 +7214,7 @@
         </p:nvGraphicFramePr>
         <p:xfrm>
           <a:off x="548640" y="1463040"/>
-          <a:ext cx="5577840" cy="3108960"/>
+          <a:ext cx="5577840" cy="3200400"/>
         </p:xfrm>
         <a:graphic xmlns:a="http://schemas.openxmlformats.org/drawingml/2006/main">
           <a:graphicData uri="http://schemas.openxmlformats.org/drawingml/2006/chart">
@@ -7112,8 +7237,8 @@
           </p:nvPr>
         </p:nvGraphicFramePr>
         <p:xfrm>
-          <a:off x="6400800" y="1463040"/>
-          <a:ext cx="5212080" cy="3108960"/>
+          <a:off x="6400800" y="1417320"/>
+          <a:ext cx="5212080" cy="3291840"/>
         </p:xfrm>
         <a:graphic>
           <a:graphicData uri="http://schemas.openxmlformats.org/drawingml/2006/table">
@@ -7124,7 +7249,7 @@
                 <a:gridCol w="1737360"/>
                 <a:gridCol w="1737360"/>
               </a:tblGrid>
-              <a:tr h="621792">
+              <a:tr h="411480">
                 <a:tc>
                   <a:txBody>
                     <a:bodyPr/>
@@ -7134,7 +7259,7 @@
                         <a:buNone/>
                       </a:pPr>
                       <a:r>
-                        <a:rPr lang="en-US" sz="1000" b="1" dirty="0">
+                        <a:rPr lang="en-US" sz="900" b="1" dirty="0">
                           <a:solidFill>
                             <a:srgbClr val="FFFFFF"/>
                           </a:solidFill>
@@ -7144,7 +7269,7 @@
                         </a:rPr>
                         <a:t>Resource</a:t>
                       </a:r>
-                      <a:endParaRPr lang="en-US" sz="1000" dirty="0">
+                      <a:endParaRPr lang="en-US" sz="900" dirty="0">
                         <a:latin typeface="Calibri" charset="0"/>
                         <a:ea typeface="Calibri" charset="0"/>
                         <a:cs typeface="Calibri" charset="0"/>
@@ -7202,7 +7327,7 @@
                         <a:buNone/>
                       </a:pPr>
                       <a:r>
-                        <a:rPr lang="en-US" sz="1000" b="1" dirty="0">
+                        <a:rPr lang="en-US" sz="900" b="1" dirty="0">
                           <a:solidFill>
                             <a:srgbClr val="FFFFFF"/>
                           </a:solidFill>
@@ -7212,7 +7337,7 @@
                         </a:rPr>
                         <a:t>SKU / Tier</a:t>
                       </a:r>
-                      <a:endParaRPr lang="en-US" sz="1000" dirty="0">
+                      <a:endParaRPr lang="en-US" sz="900" dirty="0">
                         <a:latin typeface="Calibri" charset="0"/>
                         <a:ea typeface="Calibri" charset="0"/>
                         <a:cs typeface="Calibri" charset="0"/>
@@ -7270,7 +7395,7 @@
                         <a:buNone/>
                       </a:pPr>
                       <a:r>
-                        <a:rPr lang="en-US" sz="1000" b="1" dirty="0">
+                        <a:rPr lang="en-US" sz="900" b="1" dirty="0">
                           <a:solidFill>
                             <a:srgbClr val="FFFFFF"/>
                           </a:solidFill>
@@ -7280,7 +7405,7 @@
                         </a:rPr>
                         <a:t>Role</a:t>
                       </a:r>
-                      <a:endParaRPr lang="en-US" sz="1000" dirty="0">
+                      <a:endParaRPr lang="en-US" sz="900" dirty="0">
                         <a:latin typeface="Calibri" charset="0"/>
                         <a:ea typeface="Calibri" charset="0"/>
                         <a:cs typeface="Calibri" charset="0"/>
@@ -7330,7 +7455,7 @@
                   </a:tcPr>
                 </a:tc>
               </a:tr>
-              <a:tr h="621792">
+              <a:tr h="411480">
                 <a:tc>
                   <a:txBody>
                     <a:bodyPr/>
@@ -7340,7 +7465,7 @@
                         <a:buNone/>
                       </a:pPr>
                       <a:r>
-                        <a:rPr lang="en-US" sz="1000" dirty="0">
+                        <a:rPr lang="en-US" sz="900" dirty="0">
                           <a:solidFill>
                             <a:srgbClr val="3A3A3A"/>
                           </a:solidFill>
@@ -7348,9 +7473,9 @@
                           <a:ea typeface="Calibri" pitchFamily="34" charset="-122"/>
                           <a:cs typeface="Calibri" pitchFamily="34" charset="-120"/>
                         </a:rPr>
-                        <a:t>Container Apps environment + app</a:t>
+                        <a:t>Container Apps env + app</a:t>
                       </a:r>
-                      <a:endParaRPr lang="en-US" sz="1000" dirty="0">
+                      <a:endParaRPr lang="en-US" sz="900" dirty="0">
                         <a:latin typeface="Calibri" charset="0"/>
                         <a:ea typeface="Calibri" charset="0"/>
                         <a:cs typeface="Calibri" charset="0"/>
@@ -7405,7 +7530,7 @@
                         <a:buNone/>
                       </a:pPr>
                       <a:r>
-                        <a:rPr lang="en-US" sz="1000" dirty="0">
+                        <a:rPr lang="en-US" sz="900" dirty="0">
                           <a:solidFill>
                             <a:srgbClr val="3A3A3A"/>
                           </a:solidFill>
@@ -7413,9 +7538,9 @@
                           <a:ea typeface="Calibri" pitchFamily="34" charset="-122"/>
                           <a:cs typeface="Calibri" pitchFamily="34" charset="-120"/>
                         </a:rPr>
-                        <a:t>Consumption, 0.5 vCPU / 1Gi, 1 replica (fixed)</a:t>
+                        <a:t>0.5 vCPU / 1Gi, 1 replica (fixed)</a:t>
                       </a:r>
-                      <a:endParaRPr lang="en-US" sz="1000" dirty="0">
+                      <a:endParaRPr lang="en-US" sz="900" dirty="0">
                         <a:latin typeface="Calibri" charset="0"/>
                         <a:ea typeface="Calibri" charset="0"/>
                         <a:cs typeface="Calibri" charset="0"/>
@@ -7470,7 +7595,7 @@
                         <a:buNone/>
                       </a:pPr>
                       <a:r>
-                        <a:rPr lang="en-US" sz="1000" dirty="0">
+                        <a:rPr lang="en-US" sz="900" dirty="0">
                           <a:solidFill>
                             <a:srgbClr val="3A3A3A"/>
                           </a:solidFill>
@@ -7478,9 +7603,9 @@
                           <a:ea typeface="Calibri" pitchFamily="34" charset="-122"/>
                           <a:cs typeface="Calibri" pitchFamily="34" charset="-120"/>
                         </a:rPr>
-                        <a:t>Runs the Next.js standalone server</a:t>
+                        <a:t>Runs the Next.js server, VNet-integrated</a:t>
                       </a:r>
-                      <a:endParaRPr lang="en-US" sz="1000" dirty="0">
+                      <a:endParaRPr lang="en-US" sz="900" dirty="0">
                         <a:latin typeface="Calibri" charset="0"/>
                         <a:ea typeface="Calibri" charset="0"/>
                         <a:cs typeface="Calibri" charset="0"/>
@@ -7527,7 +7652,7 @@
                   </a:tcPr>
                 </a:tc>
               </a:tr>
-              <a:tr h="621792">
+              <a:tr h="411480">
                 <a:tc>
                   <a:txBody>
                     <a:bodyPr/>
@@ -7537,7 +7662,7 @@
                         <a:buNone/>
                       </a:pPr>
                       <a:r>
-                        <a:rPr lang="en-US" sz="1000" dirty="0">
+                        <a:rPr lang="en-US" sz="900" dirty="0">
                           <a:solidFill>
                             <a:srgbClr val="3A3A3A"/>
                           </a:solidFill>
@@ -7547,7 +7672,7 @@
                         </a:rPr>
                         <a:t>Container Registry</a:t>
                       </a:r>
-                      <a:endParaRPr lang="en-US" sz="1000" dirty="0">
+                      <a:endParaRPr lang="en-US" sz="900" dirty="0">
                         <a:latin typeface="Calibri" charset="0"/>
                         <a:ea typeface="Calibri" charset="0"/>
                         <a:cs typeface="Calibri" charset="0"/>
@@ -7602,7 +7727,7 @@
                         <a:buNone/>
                       </a:pPr>
                       <a:r>
-                        <a:rPr lang="en-US" sz="1000" dirty="0">
+                        <a:rPr lang="en-US" sz="900" dirty="0">
                           <a:solidFill>
                             <a:srgbClr val="3A3A3A"/>
                           </a:solidFill>
@@ -7612,7 +7737,7 @@
                         </a:rPr>
                         <a:t>Basic</a:t>
                       </a:r>
-                      <a:endParaRPr lang="en-US" sz="1000" dirty="0">
+                      <a:endParaRPr lang="en-US" sz="900" dirty="0">
                         <a:latin typeface="Calibri" charset="0"/>
                         <a:ea typeface="Calibri" charset="0"/>
                         <a:cs typeface="Calibri" charset="0"/>
@@ -7667,7 +7792,7 @@
                         <a:buNone/>
                       </a:pPr>
                       <a:r>
-                        <a:rPr lang="en-US" sz="1000" dirty="0">
+                        <a:rPr lang="en-US" sz="900" dirty="0">
                           <a:solidFill>
                             <a:srgbClr val="3A3A3A"/>
                           </a:solidFill>
@@ -7677,7 +7802,7 @@
                         </a:rPr>
                         <a:t>Stores the built Docker image</a:t>
                       </a:r>
-                      <a:endParaRPr lang="en-US" sz="1000" dirty="0">
+                      <a:endParaRPr lang="en-US" sz="900" dirty="0">
                         <a:latin typeface="Calibri" charset="0"/>
                         <a:ea typeface="Calibri" charset="0"/>
                         <a:cs typeface="Calibri" charset="0"/>
@@ -7724,7 +7849,7 @@
                   </a:tcPr>
                 </a:tc>
               </a:tr>
-              <a:tr h="621792">
+              <a:tr h="411480">
                 <a:tc>
                   <a:txBody>
                     <a:bodyPr/>
@@ -7734,7 +7859,7 @@
                         <a:buNone/>
                       </a:pPr>
                       <a:r>
-                        <a:rPr lang="en-US" sz="1000" dirty="0">
+                        <a:rPr lang="en-US" sz="900" dirty="0">
                           <a:solidFill>
                             <a:srgbClr val="3A3A3A"/>
                           </a:solidFill>
@@ -7744,7 +7869,7 @@
                         </a:rPr>
                         <a:t>Storage Account (Table)</a:t>
                       </a:r>
-                      <a:endParaRPr lang="en-US" sz="1000" dirty="0">
+                      <a:endParaRPr lang="en-US" sz="900" dirty="0">
                         <a:latin typeface="Calibri" charset="0"/>
                         <a:ea typeface="Calibri" charset="0"/>
                         <a:cs typeface="Calibri" charset="0"/>
@@ -7799,7 +7924,7 @@
                         <a:buNone/>
                       </a:pPr>
                       <a:r>
-                        <a:rPr lang="en-US" sz="1000" dirty="0">
+                        <a:rPr lang="en-US" sz="900" dirty="0">
                           <a:solidFill>
                             <a:srgbClr val="3A3A3A"/>
                           </a:solidFill>
@@ -7807,9 +7932,9 @@
                           <a:ea typeface="Calibri" pitchFamily="34" charset="-122"/>
                           <a:cs typeface="Calibri" pitchFamily="34" charset="-120"/>
                         </a:rPr>
-                        <a:t>Standard_LRS</a:t>
+                        <a:t>Standard_LRS, public access off</a:t>
                       </a:r>
-                      <a:endParaRPr lang="en-US" sz="1000" dirty="0">
+                      <a:endParaRPr lang="en-US" sz="900" dirty="0">
                         <a:latin typeface="Calibri" charset="0"/>
                         <a:ea typeface="Calibri" charset="0"/>
                         <a:cs typeface="Calibri" charset="0"/>
@@ -7864,7 +7989,7 @@
                         <a:buNone/>
                       </a:pPr>
                       <a:r>
-                        <a:rPr lang="en-US" sz="1000" dirty="0">
+                        <a:rPr lang="en-US" sz="900" dirty="0">
                           <a:solidFill>
                             <a:srgbClr val="3A3A3A"/>
                           </a:solidFill>
@@ -7872,9 +7997,9 @@
                           <a:ea typeface="Calibri" pitchFamily="34" charset="-122"/>
                           <a:cs typeface="Calibri" pitchFamily="34" charset="-120"/>
                         </a:rPr>
-                        <a:t>Leaderboard persistence (1 table)</a:t>
+                        <a:t>Leaderboard persistence, Azure AD auth only</a:t>
                       </a:r>
-                      <a:endParaRPr lang="en-US" sz="1000" dirty="0">
+                      <a:endParaRPr lang="en-US" sz="900" dirty="0">
                         <a:latin typeface="Calibri" charset="0"/>
                         <a:ea typeface="Calibri" charset="0"/>
                         <a:cs typeface="Calibri" charset="0"/>
@@ -7921,7 +8046,7 @@
                   </a:tcPr>
                 </a:tc>
               </a:tr>
-              <a:tr h="621792">
+              <a:tr h="411480">
                 <a:tc>
                   <a:txBody>
                     <a:bodyPr/>
@@ -7931,7 +8056,7 @@
                         <a:buNone/>
                       </a:pPr>
                       <a:r>
-                        <a:rPr lang="en-US" sz="1000" dirty="0">
+                        <a:rPr lang="en-US" sz="900" dirty="0">
                           <a:solidFill>
                             <a:srgbClr val="3A3A3A"/>
                           </a:solidFill>
@@ -7939,9 +8064,9 @@
                           <a:ea typeface="Calibri" pitchFamily="34" charset="-122"/>
                           <a:cs typeface="Calibri" pitchFamily="34" charset="-120"/>
                         </a:rPr>
-                        <a:t>Log Analytics workspace</a:t>
+                        <a:t>VNet + 2 subnets</a:t>
                       </a:r>
-                      <a:endParaRPr lang="en-US" sz="1000" dirty="0">
+                      <a:endParaRPr lang="en-US" sz="900" dirty="0">
                         <a:latin typeface="Calibri" charset="0"/>
                         <a:ea typeface="Calibri" charset="0"/>
                         <a:cs typeface="Calibri" charset="0"/>
@@ -7996,7 +8121,7 @@
                         <a:buNone/>
                       </a:pPr>
                       <a:r>
-                        <a:rPr lang="en-US" sz="1000" dirty="0">
+                        <a:rPr lang="en-US" sz="900" dirty="0">
                           <a:solidFill>
                             <a:srgbClr val="3A3A3A"/>
                           </a:solidFill>
@@ -8004,9 +8129,9 @@
                           <a:ea typeface="Calibri" pitchFamily="34" charset="-122"/>
                           <a:cs typeface="Calibri" pitchFamily="34" charset="-120"/>
                         </a:rPr>
-                        <a:t>PerGB2018, 30-day retention</a:t>
+                        <a:t>10.0.0.0/16</a:t>
                       </a:r>
-                      <a:endParaRPr lang="en-US" sz="1000" dirty="0">
+                      <a:endParaRPr lang="en-US" sz="900" dirty="0">
                         <a:latin typeface="Calibri" charset="0"/>
                         <a:ea typeface="Calibri" charset="0"/>
                         <a:cs typeface="Calibri" charset="0"/>
@@ -8061,7 +8186,598 @@
                         <a:buNone/>
                       </a:pPr>
                       <a:r>
-                        <a:rPr lang="en-US" sz="1000" dirty="0">
+                        <a:rPr lang="en-US" sz="900" dirty="0">
+                          <a:solidFill>
+                            <a:srgbClr val="3A3A3A"/>
+                          </a:solidFill>
+                          <a:latin typeface="Calibri" pitchFamily="34" charset="0"/>
+                          <a:ea typeface="Calibri" pitchFamily="34" charset="-122"/>
+                          <a:cs typeface="Calibri" pitchFamily="34" charset="-120"/>
+                        </a:rPr>
+                        <a:t>Container Apps + private endpoint subnets</a:t>
+                      </a:r>
+                      <a:endParaRPr lang="en-US" sz="900" dirty="0">
+                        <a:latin typeface="Calibri" charset="0"/>
+                        <a:ea typeface="Calibri" charset="0"/>
+                        <a:cs typeface="Calibri" charset="0"/>
+                      </a:endParaRPr>
+                    </a:p>
+                  </a:txBody>
+                  <a:tcPr marL="91440" marR="91440" marT="45720" marB="45720" anchor="ctr">
+                    <a:lnL w="6350" cap="flat" cmpd="sng" algn="ctr">
+                      <a:solidFill>
+                        <a:srgbClr val="CBD5DB"/>
+                      </a:solidFill>
+                      <a:prstDash val="solid"/>
+                      <a:round/>
+                      <a:headEnd type="none" w="med" len="med"/>
+                      <a:tailEnd type="none" w="med" len="med"/>
+                    </a:lnL>
+                    <a:lnR w="6350" cap="flat" cmpd="sng" algn="ctr">
+                      <a:solidFill>
+                        <a:srgbClr val="CBD5DB"/>
+                      </a:solidFill>
+                      <a:prstDash val="solid"/>
+                      <a:round/>
+                      <a:headEnd type="none" w="med" len="med"/>
+                      <a:tailEnd type="none" w="med" len="med"/>
+                    </a:lnR>
+                    <a:lnT w="6350" cap="flat" cmpd="sng" algn="ctr">
+                      <a:solidFill>
+                        <a:srgbClr val="CBD5DB"/>
+                      </a:solidFill>
+                      <a:prstDash val="solid"/>
+                      <a:round/>
+                      <a:headEnd type="none" w="med" len="med"/>
+                      <a:tailEnd type="none" w="med" len="med"/>
+                    </a:lnT>
+                    <a:lnB w="6350" cap="flat" cmpd="sng" algn="ctr">
+                      <a:solidFill>
+                        <a:srgbClr val="CBD5DB"/>
+                      </a:solidFill>
+                      <a:prstDash val="solid"/>
+                      <a:round/>
+                      <a:headEnd type="none" w="med" len="med"/>
+                      <a:tailEnd type="none" w="med" len="med"/>
+                    </a:lnB>
+                  </a:tcPr>
+                </a:tc>
+              </a:tr>
+              <a:tr h="411480">
+                <a:tc>
+                  <a:txBody>
+                    <a:bodyPr/>
+                    <a:lstStyle/>
+                    <a:p>
+                      <a:pPr indent="0" marL="0">
+                        <a:buNone/>
+                      </a:pPr>
+                      <a:r>
+                        <a:rPr lang="en-US" sz="900" dirty="0">
+                          <a:solidFill>
+                            <a:srgbClr val="3A3A3A"/>
+                          </a:solidFill>
+                          <a:latin typeface="Calibri" pitchFamily="34" charset="0"/>
+                          <a:ea typeface="Calibri" pitchFamily="34" charset="-122"/>
+                          <a:cs typeface="Calibri" pitchFamily="34" charset="-120"/>
+                        </a:rPr>
+                        <a:t>Private endpoint + DNS zone</a:t>
+                      </a:r>
+                      <a:endParaRPr lang="en-US" sz="900" dirty="0">
+                        <a:latin typeface="Calibri" charset="0"/>
+                        <a:ea typeface="Calibri" charset="0"/>
+                        <a:cs typeface="Calibri" charset="0"/>
+                      </a:endParaRPr>
+                    </a:p>
+                  </a:txBody>
+                  <a:tcPr marL="91440" marR="91440" marT="45720" marB="45720" anchor="ctr">
+                    <a:lnL w="6350" cap="flat" cmpd="sng" algn="ctr">
+                      <a:solidFill>
+                        <a:srgbClr val="CBD5DB"/>
+                      </a:solidFill>
+                      <a:prstDash val="solid"/>
+                      <a:round/>
+                      <a:headEnd type="none" w="med" len="med"/>
+                      <a:tailEnd type="none" w="med" len="med"/>
+                    </a:lnL>
+                    <a:lnR w="6350" cap="flat" cmpd="sng" algn="ctr">
+                      <a:solidFill>
+                        <a:srgbClr val="CBD5DB"/>
+                      </a:solidFill>
+                      <a:prstDash val="solid"/>
+                      <a:round/>
+                      <a:headEnd type="none" w="med" len="med"/>
+                      <a:tailEnd type="none" w="med" len="med"/>
+                    </a:lnR>
+                    <a:lnT w="6350" cap="flat" cmpd="sng" algn="ctr">
+                      <a:solidFill>
+                        <a:srgbClr val="CBD5DB"/>
+                      </a:solidFill>
+                      <a:prstDash val="solid"/>
+                      <a:round/>
+                      <a:headEnd type="none" w="med" len="med"/>
+                      <a:tailEnd type="none" w="med" len="med"/>
+                    </a:lnT>
+                    <a:lnB w="6350" cap="flat" cmpd="sng" algn="ctr">
+                      <a:solidFill>
+                        <a:srgbClr val="CBD5DB"/>
+                      </a:solidFill>
+                      <a:prstDash val="solid"/>
+                      <a:round/>
+                      <a:headEnd type="none" w="med" len="med"/>
+                      <a:tailEnd type="none" w="med" len="med"/>
+                    </a:lnB>
+                  </a:tcPr>
+                </a:tc>
+                <a:tc>
+                  <a:txBody>
+                    <a:bodyPr/>
+                    <a:lstStyle/>
+                    <a:p>
+                      <a:pPr indent="0" marL="0">
+                        <a:buNone/>
+                      </a:pPr>
+                      <a:r>
+                        <a:rPr lang="en-US" sz="900" dirty="0">
+                          <a:solidFill>
+                            <a:srgbClr val="3A3A3A"/>
+                          </a:solidFill>
+                          <a:latin typeface="Calibri" pitchFamily="34" charset="0"/>
+                          <a:ea typeface="Calibri" pitchFamily="34" charset="-122"/>
+                          <a:cs typeface="Calibri" pitchFamily="34" charset="-120"/>
+                        </a:rPr>
+                        <a:t>privatelink.table...</a:t>
+                      </a:r>
+                      <a:endParaRPr lang="en-US" sz="900" dirty="0">
+                        <a:latin typeface="Calibri" charset="0"/>
+                        <a:ea typeface="Calibri" charset="0"/>
+                        <a:cs typeface="Calibri" charset="0"/>
+                      </a:endParaRPr>
+                    </a:p>
+                  </a:txBody>
+                  <a:tcPr marL="91440" marR="91440" marT="45720" marB="45720" anchor="ctr">
+                    <a:lnL w="6350" cap="flat" cmpd="sng" algn="ctr">
+                      <a:solidFill>
+                        <a:srgbClr val="CBD5DB"/>
+                      </a:solidFill>
+                      <a:prstDash val="solid"/>
+                      <a:round/>
+                      <a:headEnd type="none" w="med" len="med"/>
+                      <a:tailEnd type="none" w="med" len="med"/>
+                    </a:lnL>
+                    <a:lnR w="6350" cap="flat" cmpd="sng" algn="ctr">
+                      <a:solidFill>
+                        <a:srgbClr val="CBD5DB"/>
+                      </a:solidFill>
+                      <a:prstDash val="solid"/>
+                      <a:round/>
+                      <a:headEnd type="none" w="med" len="med"/>
+                      <a:tailEnd type="none" w="med" len="med"/>
+                    </a:lnR>
+                    <a:lnT w="6350" cap="flat" cmpd="sng" algn="ctr">
+                      <a:solidFill>
+                        <a:srgbClr val="CBD5DB"/>
+                      </a:solidFill>
+                      <a:prstDash val="solid"/>
+                      <a:round/>
+                      <a:headEnd type="none" w="med" len="med"/>
+                      <a:tailEnd type="none" w="med" len="med"/>
+                    </a:lnT>
+                    <a:lnB w="6350" cap="flat" cmpd="sng" algn="ctr">
+                      <a:solidFill>
+                        <a:srgbClr val="CBD5DB"/>
+                      </a:solidFill>
+                      <a:prstDash val="solid"/>
+                      <a:round/>
+                      <a:headEnd type="none" w="med" len="med"/>
+                      <a:tailEnd type="none" w="med" len="med"/>
+                    </a:lnB>
+                  </a:tcPr>
+                </a:tc>
+                <a:tc>
+                  <a:txBody>
+                    <a:bodyPr/>
+                    <a:lstStyle/>
+                    <a:p>
+                      <a:pPr indent="0" marL="0">
+                        <a:buNone/>
+                      </a:pPr>
+                      <a:r>
+                        <a:rPr lang="en-US" sz="900" dirty="0">
+                          <a:solidFill>
+                            <a:srgbClr val="3A3A3A"/>
+                          </a:solidFill>
+                          <a:latin typeface="Calibri" pitchFamily="34" charset="0"/>
+                          <a:ea typeface="Calibri" pitchFamily="34" charset="-122"/>
+                          <a:cs typeface="Calibri" pitchFamily="34" charset="-120"/>
+                        </a:rPr>
+                        <a:t>Private path to Table Storage</a:t>
+                      </a:r>
+                      <a:endParaRPr lang="en-US" sz="900" dirty="0">
+                        <a:latin typeface="Calibri" charset="0"/>
+                        <a:ea typeface="Calibri" charset="0"/>
+                        <a:cs typeface="Calibri" charset="0"/>
+                      </a:endParaRPr>
+                    </a:p>
+                  </a:txBody>
+                  <a:tcPr marL="91440" marR="91440" marT="45720" marB="45720" anchor="ctr">
+                    <a:lnL w="6350" cap="flat" cmpd="sng" algn="ctr">
+                      <a:solidFill>
+                        <a:srgbClr val="CBD5DB"/>
+                      </a:solidFill>
+                      <a:prstDash val="solid"/>
+                      <a:round/>
+                      <a:headEnd type="none" w="med" len="med"/>
+                      <a:tailEnd type="none" w="med" len="med"/>
+                    </a:lnL>
+                    <a:lnR w="6350" cap="flat" cmpd="sng" algn="ctr">
+                      <a:solidFill>
+                        <a:srgbClr val="CBD5DB"/>
+                      </a:solidFill>
+                      <a:prstDash val="solid"/>
+                      <a:round/>
+                      <a:headEnd type="none" w="med" len="med"/>
+                      <a:tailEnd type="none" w="med" len="med"/>
+                    </a:lnR>
+                    <a:lnT w="6350" cap="flat" cmpd="sng" algn="ctr">
+                      <a:solidFill>
+                        <a:srgbClr val="CBD5DB"/>
+                      </a:solidFill>
+                      <a:prstDash val="solid"/>
+                      <a:round/>
+                      <a:headEnd type="none" w="med" len="med"/>
+                      <a:tailEnd type="none" w="med" len="med"/>
+                    </a:lnT>
+                    <a:lnB w="6350" cap="flat" cmpd="sng" algn="ctr">
+                      <a:solidFill>
+                        <a:srgbClr val="CBD5DB"/>
+                      </a:solidFill>
+                      <a:prstDash val="solid"/>
+                      <a:round/>
+                      <a:headEnd type="none" w="med" len="med"/>
+                      <a:tailEnd type="none" w="med" len="med"/>
+                    </a:lnB>
+                  </a:tcPr>
+                </a:tc>
+              </a:tr>
+              <a:tr h="411480">
+                <a:tc>
+                  <a:txBody>
+                    <a:bodyPr/>
+                    <a:lstStyle/>
+                    <a:p>
+                      <a:pPr indent="0" marL="0">
+                        <a:buNone/>
+                      </a:pPr>
+                      <a:r>
+                        <a:rPr lang="en-US" sz="900" dirty="0">
+                          <a:solidFill>
+                            <a:srgbClr val="3A3A3A"/>
+                          </a:solidFill>
+                          <a:latin typeface="Calibri" pitchFamily="34" charset="0"/>
+                          <a:ea typeface="Calibri" pitchFamily="34" charset="-122"/>
+                          <a:cs typeface="Calibri" pitchFamily="34" charset="-120"/>
+                        </a:rPr>
+                        <a:t>User-assigned identity</a:t>
+                      </a:r>
+                      <a:endParaRPr lang="en-US" sz="900" dirty="0">
+                        <a:latin typeface="Calibri" charset="0"/>
+                        <a:ea typeface="Calibri" charset="0"/>
+                        <a:cs typeface="Calibri" charset="0"/>
+                      </a:endParaRPr>
+                    </a:p>
+                  </a:txBody>
+                  <a:tcPr marL="91440" marR="91440" marT="45720" marB="45720" anchor="ctr">
+                    <a:lnL w="6350" cap="flat" cmpd="sng" algn="ctr">
+                      <a:solidFill>
+                        <a:srgbClr val="CBD5DB"/>
+                      </a:solidFill>
+                      <a:prstDash val="solid"/>
+                      <a:round/>
+                      <a:headEnd type="none" w="med" len="med"/>
+                      <a:tailEnd type="none" w="med" len="med"/>
+                    </a:lnL>
+                    <a:lnR w="6350" cap="flat" cmpd="sng" algn="ctr">
+                      <a:solidFill>
+                        <a:srgbClr val="CBD5DB"/>
+                      </a:solidFill>
+                      <a:prstDash val="solid"/>
+                      <a:round/>
+                      <a:headEnd type="none" w="med" len="med"/>
+                      <a:tailEnd type="none" w="med" len="med"/>
+                    </a:lnR>
+                    <a:lnT w="6350" cap="flat" cmpd="sng" algn="ctr">
+                      <a:solidFill>
+                        <a:srgbClr val="CBD5DB"/>
+                      </a:solidFill>
+                      <a:prstDash val="solid"/>
+                      <a:round/>
+                      <a:headEnd type="none" w="med" len="med"/>
+                      <a:tailEnd type="none" w="med" len="med"/>
+                    </a:lnT>
+                    <a:lnB w="6350" cap="flat" cmpd="sng" algn="ctr">
+                      <a:solidFill>
+                        <a:srgbClr val="CBD5DB"/>
+                      </a:solidFill>
+                      <a:prstDash val="solid"/>
+                      <a:round/>
+                      <a:headEnd type="none" w="med" len="med"/>
+                      <a:tailEnd type="none" w="med" len="med"/>
+                    </a:lnB>
+                  </a:tcPr>
+                </a:tc>
+                <a:tc>
+                  <a:txBody>
+                    <a:bodyPr/>
+                    <a:lstStyle/>
+                    <a:p>
+                      <a:pPr indent="0" marL="0">
+                        <a:buNone/>
+                      </a:pPr>
+                      <a:r>
+                        <a:rPr lang="en-US" sz="900" dirty="0">
+                          <a:solidFill>
+                            <a:srgbClr val="3A3A3A"/>
+                          </a:solidFill>
+                          <a:latin typeface="Calibri" pitchFamily="34" charset="0"/>
+                          <a:ea typeface="Calibri" pitchFamily="34" charset="-122"/>
+                          <a:cs typeface="Calibri" pitchFamily="34" charset="-120"/>
+                        </a:rPr>
+                        <a:t>—</a:t>
+                      </a:r>
+                      <a:endParaRPr lang="en-US" sz="900" dirty="0">
+                        <a:latin typeface="Calibri" charset="0"/>
+                        <a:ea typeface="Calibri" charset="0"/>
+                        <a:cs typeface="Calibri" charset="0"/>
+                      </a:endParaRPr>
+                    </a:p>
+                  </a:txBody>
+                  <a:tcPr marL="91440" marR="91440" marT="45720" marB="45720" anchor="ctr">
+                    <a:lnL w="6350" cap="flat" cmpd="sng" algn="ctr">
+                      <a:solidFill>
+                        <a:srgbClr val="CBD5DB"/>
+                      </a:solidFill>
+                      <a:prstDash val="solid"/>
+                      <a:round/>
+                      <a:headEnd type="none" w="med" len="med"/>
+                      <a:tailEnd type="none" w="med" len="med"/>
+                    </a:lnL>
+                    <a:lnR w="6350" cap="flat" cmpd="sng" algn="ctr">
+                      <a:solidFill>
+                        <a:srgbClr val="CBD5DB"/>
+                      </a:solidFill>
+                      <a:prstDash val="solid"/>
+                      <a:round/>
+                      <a:headEnd type="none" w="med" len="med"/>
+                      <a:tailEnd type="none" w="med" len="med"/>
+                    </a:lnR>
+                    <a:lnT w="6350" cap="flat" cmpd="sng" algn="ctr">
+                      <a:solidFill>
+                        <a:srgbClr val="CBD5DB"/>
+                      </a:solidFill>
+                      <a:prstDash val="solid"/>
+                      <a:round/>
+                      <a:headEnd type="none" w="med" len="med"/>
+                      <a:tailEnd type="none" w="med" len="med"/>
+                    </a:lnT>
+                    <a:lnB w="6350" cap="flat" cmpd="sng" algn="ctr">
+                      <a:solidFill>
+                        <a:srgbClr val="CBD5DB"/>
+                      </a:solidFill>
+                      <a:prstDash val="solid"/>
+                      <a:round/>
+                      <a:headEnd type="none" w="med" len="med"/>
+                      <a:tailEnd type="none" w="med" len="med"/>
+                    </a:lnB>
+                  </a:tcPr>
+                </a:tc>
+                <a:tc>
+                  <a:txBody>
+                    <a:bodyPr/>
+                    <a:lstStyle/>
+                    <a:p>
+                      <a:pPr indent="0" marL="0">
+                        <a:buNone/>
+                      </a:pPr>
+                      <a:r>
+                        <a:rPr lang="en-US" sz="900" dirty="0">
+                          <a:solidFill>
+                            <a:srgbClr val="3A3A3A"/>
+                          </a:solidFill>
+                          <a:latin typeface="Calibri" pitchFamily="34" charset="0"/>
+                          <a:ea typeface="Calibri" pitchFamily="34" charset="-122"/>
+                          <a:cs typeface="Calibri" pitchFamily="34" charset="-120"/>
+                        </a:rPr>
+                        <a:t>ACR pull + Table Storage data access</a:t>
+                      </a:r>
+                      <a:endParaRPr lang="en-US" sz="900" dirty="0">
+                        <a:latin typeface="Calibri" charset="0"/>
+                        <a:ea typeface="Calibri" charset="0"/>
+                        <a:cs typeface="Calibri" charset="0"/>
+                      </a:endParaRPr>
+                    </a:p>
+                  </a:txBody>
+                  <a:tcPr marL="91440" marR="91440" marT="45720" marB="45720" anchor="ctr">
+                    <a:lnL w="6350" cap="flat" cmpd="sng" algn="ctr">
+                      <a:solidFill>
+                        <a:srgbClr val="CBD5DB"/>
+                      </a:solidFill>
+                      <a:prstDash val="solid"/>
+                      <a:round/>
+                      <a:headEnd type="none" w="med" len="med"/>
+                      <a:tailEnd type="none" w="med" len="med"/>
+                    </a:lnL>
+                    <a:lnR w="6350" cap="flat" cmpd="sng" algn="ctr">
+                      <a:solidFill>
+                        <a:srgbClr val="CBD5DB"/>
+                      </a:solidFill>
+                      <a:prstDash val="solid"/>
+                      <a:round/>
+                      <a:headEnd type="none" w="med" len="med"/>
+                      <a:tailEnd type="none" w="med" len="med"/>
+                    </a:lnR>
+                    <a:lnT w="6350" cap="flat" cmpd="sng" algn="ctr">
+                      <a:solidFill>
+                        <a:srgbClr val="CBD5DB"/>
+                      </a:solidFill>
+                      <a:prstDash val="solid"/>
+                      <a:round/>
+                      <a:headEnd type="none" w="med" len="med"/>
+                      <a:tailEnd type="none" w="med" len="med"/>
+                    </a:lnT>
+                    <a:lnB w="6350" cap="flat" cmpd="sng" algn="ctr">
+                      <a:solidFill>
+                        <a:srgbClr val="CBD5DB"/>
+                      </a:solidFill>
+                      <a:prstDash val="solid"/>
+                      <a:round/>
+                      <a:headEnd type="none" w="med" len="med"/>
+                      <a:tailEnd type="none" w="med" len="med"/>
+                    </a:lnB>
+                  </a:tcPr>
+                </a:tc>
+              </a:tr>
+              <a:tr h="411480">
+                <a:tc>
+                  <a:txBody>
+                    <a:bodyPr/>
+                    <a:lstStyle/>
+                    <a:p>
+                      <a:pPr indent="0" marL="0">
+                        <a:buNone/>
+                      </a:pPr>
+                      <a:r>
+                        <a:rPr lang="en-US" sz="900" dirty="0">
+                          <a:solidFill>
+                            <a:srgbClr val="3A3A3A"/>
+                          </a:solidFill>
+                          <a:latin typeface="Calibri" pitchFamily="34" charset="0"/>
+                          <a:ea typeface="Calibri" pitchFamily="34" charset="-122"/>
+                          <a:cs typeface="Calibri" pitchFamily="34" charset="-120"/>
+                        </a:rPr>
+                        <a:t>Log Analytics workspace</a:t>
+                      </a:r>
+                      <a:endParaRPr lang="en-US" sz="900" dirty="0">
+                        <a:latin typeface="Calibri" charset="0"/>
+                        <a:ea typeface="Calibri" charset="0"/>
+                        <a:cs typeface="Calibri" charset="0"/>
+                      </a:endParaRPr>
+                    </a:p>
+                  </a:txBody>
+                  <a:tcPr marL="91440" marR="91440" marT="45720" marB="45720" anchor="ctr">
+                    <a:lnL w="6350" cap="flat" cmpd="sng" algn="ctr">
+                      <a:solidFill>
+                        <a:srgbClr val="CBD5DB"/>
+                      </a:solidFill>
+                      <a:prstDash val="solid"/>
+                      <a:round/>
+                      <a:headEnd type="none" w="med" len="med"/>
+                      <a:tailEnd type="none" w="med" len="med"/>
+                    </a:lnL>
+                    <a:lnR w="6350" cap="flat" cmpd="sng" algn="ctr">
+                      <a:solidFill>
+                        <a:srgbClr val="CBD5DB"/>
+                      </a:solidFill>
+                      <a:prstDash val="solid"/>
+                      <a:round/>
+                      <a:headEnd type="none" w="med" len="med"/>
+                      <a:tailEnd type="none" w="med" len="med"/>
+                    </a:lnR>
+                    <a:lnT w="6350" cap="flat" cmpd="sng" algn="ctr">
+                      <a:solidFill>
+                        <a:srgbClr val="CBD5DB"/>
+                      </a:solidFill>
+                      <a:prstDash val="solid"/>
+                      <a:round/>
+                      <a:headEnd type="none" w="med" len="med"/>
+                      <a:tailEnd type="none" w="med" len="med"/>
+                    </a:lnT>
+                    <a:lnB w="6350" cap="flat" cmpd="sng" algn="ctr">
+                      <a:solidFill>
+                        <a:srgbClr val="CBD5DB"/>
+                      </a:solidFill>
+                      <a:prstDash val="solid"/>
+                      <a:round/>
+                      <a:headEnd type="none" w="med" len="med"/>
+                      <a:tailEnd type="none" w="med" len="med"/>
+                    </a:lnB>
+                  </a:tcPr>
+                </a:tc>
+                <a:tc>
+                  <a:txBody>
+                    <a:bodyPr/>
+                    <a:lstStyle/>
+                    <a:p>
+                      <a:pPr indent="0" marL="0">
+                        <a:buNone/>
+                      </a:pPr>
+                      <a:r>
+                        <a:rPr lang="en-US" sz="900" dirty="0">
+                          <a:solidFill>
+                            <a:srgbClr val="3A3A3A"/>
+                          </a:solidFill>
+                          <a:latin typeface="Calibri" pitchFamily="34" charset="0"/>
+                          <a:ea typeface="Calibri" pitchFamily="34" charset="-122"/>
+                          <a:cs typeface="Calibri" pitchFamily="34" charset="-120"/>
+                        </a:rPr>
+                        <a:t>PerGB2018, 30-day retention</a:t>
+                      </a:r>
+                      <a:endParaRPr lang="en-US" sz="900" dirty="0">
+                        <a:latin typeface="Calibri" charset="0"/>
+                        <a:ea typeface="Calibri" charset="0"/>
+                        <a:cs typeface="Calibri" charset="0"/>
+                      </a:endParaRPr>
+                    </a:p>
+                  </a:txBody>
+                  <a:tcPr marL="91440" marR="91440" marT="45720" marB="45720" anchor="ctr">
+                    <a:lnL w="6350" cap="flat" cmpd="sng" algn="ctr">
+                      <a:solidFill>
+                        <a:srgbClr val="CBD5DB"/>
+                      </a:solidFill>
+                      <a:prstDash val="solid"/>
+                      <a:round/>
+                      <a:headEnd type="none" w="med" len="med"/>
+                      <a:tailEnd type="none" w="med" len="med"/>
+                    </a:lnL>
+                    <a:lnR w="6350" cap="flat" cmpd="sng" algn="ctr">
+                      <a:solidFill>
+                        <a:srgbClr val="CBD5DB"/>
+                      </a:solidFill>
+                      <a:prstDash val="solid"/>
+                      <a:round/>
+                      <a:headEnd type="none" w="med" len="med"/>
+                      <a:tailEnd type="none" w="med" len="med"/>
+                    </a:lnR>
+                    <a:lnT w="6350" cap="flat" cmpd="sng" algn="ctr">
+                      <a:solidFill>
+                        <a:srgbClr val="CBD5DB"/>
+                      </a:solidFill>
+                      <a:prstDash val="solid"/>
+                      <a:round/>
+                      <a:headEnd type="none" w="med" len="med"/>
+                      <a:tailEnd type="none" w="med" len="med"/>
+                    </a:lnT>
+                    <a:lnB w="6350" cap="flat" cmpd="sng" algn="ctr">
+                      <a:solidFill>
+                        <a:srgbClr val="CBD5DB"/>
+                      </a:solidFill>
+                      <a:prstDash val="solid"/>
+                      <a:round/>
+                      <a:headEnd type="none" w="med" len="med"/>
+                      <a:tailEnd type="none" w="med" len="med"/>
+                    </a:lnB>
+                  </a:tcPr>
+                </a:tc>
+                <a:tc>
+                  <a:txBody>
+                    <a:bodyPr/>
+                    <a:lstStyle/>
+                    <a:p>
+                      <a:pPr indent="0" marL="0">
+                        <a:buNone/>
+                      </a:pPr>
+                      <a:r>
+                        <a:rPr lang="en-US" sz="900" dirty="0">
                           <a:solidFill>
                             <a:srgbClr val="3A3A3A"/>
                           </a:solidFill>
@@ -8071,7 +8787,7 @@
                         </a:rPr>
                         <a:t>Container Apps log destination</a:t>
                       </a:r>
-                      <a:endParaRPr lang="en-US" sz="1000" dirty="0">
+                      <a:endParaRPr lang="en-US" sz="900" dirty="0">
                         <a:latin typeface="Calibri" charset="0"/>
                         <a:ea typeface="Calibri" charset="0"/>
                         <a:cs typeface="Calibri" charset="0"/>
@@ -8130,8 +8846,8 @@
         </p:nvSpPr>
         <p:spPr>
           <a:xfrm>
-            <a:off x="548640" y="4846320"/>
-            <a:ext cx="11064240" cy="822960"/>
+            <a:off x="548640" y="4937760"/>
+            <a:ext cx="11064240" cy="640080"/>
           </a:xfrm>
           <a:prstGeom prst="rect">
             <a:avLst/>
@@ -8147,7 +8863,7 @@
               <a:buNone/>
             </a:pPr>
             <a:r>
-              <a:rPr lang="en-US" sz="1250" i="1" dirty="0">
+              <a:rPr lang="en-US" sz="1200" i="1" dirty="0">
                 <a:solidFill>
                   <a:srgbClr val="21295C"/>
                 </a:solidFill>
@@ -8155,9 +8871,9 @@
                 <a:ea typeface="Calibri" pitchFamily="34" charset="-122"/>
                 <a:cs typeface="Calibri" pitchFamily="34" charset="-120"/>
               </a:rPr>
-              <a:t>No compute autoscaling: minReplicas = maxReplicas = 1, a deliberate constraint because the leaderboard's session-token and rate-limit state is in-process only (not backed by Redis or another shared store) — a scope decision appropriate for a private evaluation project, not an oversight.</a:t>
-            </a:r>
-            <a:endParaRPr lang="en-US" sz="1250" dirty="0"/>
+              <a:t>No compute autoscaling: minReplicas = maxReplicas = 1 — the leaderboard's session-token/rate-limit state is in-process only, a deliberate scope decision for this private evaluation project.</a:t>
+            </a:r>
+            <a:endParaRPr lang="en-US" sz="1200" dirty="0"/>
           </a:p>
         </p:txBody>
       </p:sp>
@@ -8169,7 +8885,7 @@
         </p:nvSpPr>
         <p:spPr>
           <a:xfrm>
-            <a:off x="548640" y="5669280"/>
+            <a:off x="548640" y="5577840"/>
             <a:ext cx="11064240" cy="822960"/>
           </a:xfrm>
           <a:prstGeom prst="rect">
@@ -8186,7 +8902,7 @@
               <a:buNone/>
             </a:pPr>
             <a:r>
-              <a:rPr lang="en-US" sz="1250" dirty="0">
+              <a:rPr lang="en-US" sz="1200" dirty="0">
                 <a:solidFill>
                   <a:srgbClr val="3A3A3A"/>
                 </a:solidFill>
@@ -8194,9 +8910,9 @@
                 <a:ea typeface="Calibri" pitchFamily="34" charset="-122"/>
                 <a:cs typeface="Calibri" pitchFamily="34" charset="-120"/>
               </a:rPr>
-              <a:t>Identity &amp; security: Container App uses a system-assigned managed identity with an AcrPull role assignment scoped to the registry (no admin credentials); CI/CD authenticates via OIDC federated credentials (no long-lived secrets stored in GitHub).</a:t>
-            </a:r>
-            <a:endParaRPr lang="en-US" sz="1250" dirty="0"/>
+              <a:t>Security: storage account has public network access AND shared-key auth both disabled (tenant policy) — access is via private endpoint + Azure AD only. CI/CD authenticates via OIDC federated credentials (no stored secrets).</a:t>
+            </a:r>
+            <a:endParaRPr lang="en-US" sz="1200" dirty="0"/>
           </a:p>
         </p:txBody>
       </p:sp>
@@ -8304,7 +9020,7 @@
                 <a:ea typeface="Calibri" pitchFamily="34" charset="-122"/>
                 <a:cs typeface="Calibri" pitchFamily="34" charset="-120"/>
               </a:rPr>
-              <a:t>8 tracer-bullet tickets, tracked to closure</a:t>
+              <a:t>8 tracer-bullet tickets — all shipped</a:t>
             </a:r>
             <a:endParaRPr lang="en-US" sz="1300" dirty="0"/>
           </a:p>
@@ -8318,7 +9034,7 @@
         </p:nvGraphicFramePr>
         <p:xfrm>
           <a:off x="731520" y="1554480"/>
-          <a:ext cx="4754880" cy="4206240"/>
+          <a:ext cx="4754880" cy="4023360"/>
         </p:xfrm>
         <a:graphic xmlns:a="http://schemas.openxmlformats.org/drawingml/2006/main">
           <a:graphicData uri="http://schemas.openxmlformats.org/drawingml/2006/chart">
@@ -9145,7 +9861,7 @@
             <a:avLst/>
           </a:prstGeom>
           <a:solidFill>
-            <a:srgbClr val="F96167"/>
+            <a:srgbClr val="3FA796"/>
           </a:solidFill>
           <a:ln/>
         </p:spPr>
@@ -9180,7 +9896,7 @@
                   <a:srgbClr val="FFFFFF"/>
                 </a:solidFill>
               </a:rPr>
-              <a:t>…</a:t>
+              <a:t>✓</a:t>
             </a:r>
             <a:endParaRPr lang="en-US" sz="1300" dirty="0"/>
           </a:p>
@@ -9258,7 +9974,7 @@
                 <a:ea typeface="Calibri" pitchFamily="34" charset="-122"/>
                 <a:cs typeface="Calibri" pitchFamily="34" charset="-120"/>
               </a:rPr>
-              <a:t>Azure infra + CI/CD</a:t>
+              <a:t>Azure infra + CI/CD (+ VNet)</a:t>
             </a:r>
             <a:endParaRPr lang="en-US" sz="1200" dirty="0"/>
           </a:p>
@@ -9279,7 +9995,7 @@
             <a:avLst/>
           </a:prstGeom>
           <a:solidFill>
-            <a:srgbClr val="F96167"/>
+            <a:srgbClr val="3FA796"/>
           </a:solidFill>
           <a:ln/>
         </p:spPr>
@@ -9314,7 +10030,7 @@
                   <a:srgbClr val="FFFFFF"/>
                 </a:solidFill>
               </a:rPr>
-              <a:t>…</a:t>
+              <a:t>✓</a:t>
             </a:r>
             <a:endParaRPr lang="en-US" sz="1300" dirty="0"/>
           </a:p>
@@ -9516,12 +10232,12 @@
         </p:nvSpPr>
         <p:spPr>
           <a:xfrm>
-            <a:off x="790956" y="2194560"/>
-            <a:ext cx="2011680" cy="1371600"/>
+            <a:off x="790956" y="1920240"/>
+            <a:ext cx="2011680" cy="1280160"/>
           </a:xfrm>
           <a:prstGeom prst="roundRect">
             <a:avLst>
-              <a:gd name="adj" fmla="val 5333"/>
+              <a:gd name="adj" fmla="val 5714"/>
             </a:avLst>
           </a:prstGeom>
           <a:solidFill>
@@ -9538,8 +10254,8 @@
         </p:nvSpPr>
         <p:spPr>
           <a:xfrm>
-            <a:off x="882396" y="2194560"/>
-            <a:ext cx="1828800" cy="1371600"/>
+            <a:off x="882396" y="1920240"/>
+            <a:ext cx="1828800" cy="1280160"/>
           </a:xfrm>
           <a:prstGeom prst="rect">
             <a:avLst/>
@@ -9594,7 +10310,7 @@
         </p:nvSpPr>
         <p:spPr>
           <a:xfrm>
-            <a:off x="2802636" y="2834640"/>
+            <a:off x="2802636" y="2514600"/>
             <a:ext cx="137160" cy="54864"/>
           </a:xfrm>
           <a:prstGeom prst="rect">
@@ -9614,12 +10330,12 @@
         </p:nvSpPr>
         <p:spPr>
           <a:xfrm>
-            <a:off x="2939796" y="2194560"/>
-            <a:ext cx="2011680" cy="1371600"/>
+            <a:off x="2939796" y="1920240"/>
+            <a:ext cx="2011680" cy="1280160"/>
           </a:xfrm>
           <a:prstGeom prst="roundRect">
             <a:avLst>
-              <a:gd name="adj" fmla="val 5333"/>
+              <a:gd name="adj" fmla="val 5714"/>
             </a:avLst>
           </a:prstGeom>
           <a:solidFill>
@@ -9636,8 +10352,8 @@
         </p:nvSpPr>
         <p:spPr>
           <a:xfrm>
-            <a:off x="3031236" y="2194560"/>
-            <a:ext cx="1828800" cy="1371600"/>
+            <a:off x="3031236" y="1920240"/>
+            <a:ext cx="1828800" cy="1280160"/>
           </a:xfrm>
           <a:prstGeom prst="rect">
             <a:avLst/>
@@ -9692,7 +10408,7 @@
         </p:nvSpPr>
         <p:spPr>
           <a:xfrm>
-            <a:off x="4951476" y="2834640"/>
+            <a:off x="4951476" y="2514600"/>
             <a:ext cx="137160" cy="54864"/>
           </a:xfrm>
           <a:prstGeom prst="rect">
@@ -9712,12 +10428,12 @@
         </p:nvSpPr>
         <p:spPr>
           <a:xfrm>
-            <a:off x="5088636" y="2194560"/>
-            <a:ext cx="2011680" cy="1371600"/>
+            <a:off x="5088636" y="1920240"/>
+            <a:ext cx="2011680" cy="1280160"/>
           </a:xfrm>
           <a:prstGeom prst="roundRect">
             <a:avLst>
-              <a:gd name="adj" fmla="val 5333"/>
+              <a:gd name="adj" fmla="val 5714"/>
             </a:avLst>
           </a:prstGeom>
           <a:solidFill>
@@ -9734,8 +10450,8 @@
         </p:nvSpPr>
         <p:spPr>
           <a:xfrm>
-            <a:off x="5180076" y="2194560"/>
-            <a:ext cx="1828800" cy="1371600"/>
+            <a:off x="5180076" y="1920240"/>
+            <a:ext cx="1828800" cy="1280160"/>
           </a:xfrm>
           <a:prstGeom prst="rect">
             <a:avLst/>
@@ -9790,7 +10506,7 @@
         </p:nvSpPr>
         <p:spPr>
           <a:xfrm>
-            <a:off x="7100316" y="2834640"/>
+            <a:off x="7100316" y="2514600"/>
             <a:ext cx="137160" cy="54864"/>
           </a:xfrm>
           <a:prstGeom prst="rect">
@@ -9810,12 +10526,12 @@
         </p:nvSpPr>
         <p:spPr>
           <a:xfrm>
-            <a:off x="7237476" y="2194560"/>
-            <a:ext cx="2011680" cy="1371600"/>
+            <a:off x="7237476" y="1920240"/>
+            <a:ext cx="2011680" cy="1280160"/>
           </a:xfrm>
           <a:prstGeom prst="roundRect">
             <a:avLst>
-              <a:gd name="adj" fmla="val 5333"/>
+              <a:gd name="adj" fmla="val 5714"/>
             </a:avLst>
           </a:prstGeom>
           <a:solidFill>
@@ -9832,8 +10548,8 @@
         </p:nvSpPr>
         <p:spPr>
           <a:xfrm>
-            <a:off x="7328916" y="2194560"/>
-            <a:ext cx="1828800" cy="1371600"/>
+            <a:off x="7328916" y="1920240"/>
+            <a:ext cx="1828800" cy="1280160"/>
           </a:xfrm>
           <a:prstGeom prst="rect">
             <a:avLst/>
@@ -9888,7 +10604,7 @@
         </p:nvSpPr>
         <p:spPr>
           <a:xfrm>
-            <a:off x="9249156" y="2834640"/>
+            <a:off x="9249156" y="2514600"/>
             <a:ext cx="137160" cy="54864"/>
           </a:xfrm>
           <a:prstGeom prst="rect">
@@ -9908,12 +10624,12 @@
         </p:nvSpPr>
         <p:spPr>
           <a:xfrm>
-            <a:off x="9386316" y="2194560"/>
-            <a:ext cx="2011680" cy="1371600"/>
+            <a:off x="9386316" y="1920240"/>
+            <a:ext cx="2011680" cy="1280160"/>
           </a:xfrm>
           <a:prstGeom prst="roundRect">
             <a:avLst>
-              <a:gd name="adj" fmla="val 5333"/>
+              <a:gd name="adj" fmla="val 5714"/>
             </a:avLst>
           </a:prstGeom>
           <a:solidFill>
@@ -9930,8 +10646,8 @@
         </p:nvSpPr>
         <p:spPr>
           <a:xfrm>
-            <a:off x="9477756" y="2194560"/>
-            <a:ext cx="1828800" cy="1371600"/>
+            <a:off x="9477756" y="1920240"/>
+            <a:ext cx="1828800" cy="1280160"/>
           </a:xfrm>
           <a:prstGeom prst="rect">
             <a:avLst/>
@@ -9986,8 +10702,8 @@
         </p:nvSpPr>
         <p:spPr>
           <a:xfrm>
-            <a:off x="548640" y="4023360"/>
-            <a:ext cx="11064240" cy="548640"/>
+            <a:off x="640080" y="3566160"/>
+            <a:ext cx="10881360" cy="548640"/>
           </a:xfrm>
           <a:prstGeom prst="rect">
             <a:avLst/>
@@ -10011,7 +10727,7 @@
                 <a:ea typeface="Calibri" pitchFamily="34" charset="-122"/>
                 <a:cs typeface="Calibri" pitchFamily="34" charset="-120"/>
               </a:rPr>
-              <a:t>No long-lived secrets stored in the repository: GitHub Actions exchanges a short-lived OIDC token for Azure access at run time via a federated credential trusting this repository's main branch.</a:t>
+              <a:t>No long-lived secrets stored in the repository: GitHub Actions exchanges a short-lived OIDC token for Azure access via a federated credential trusting this repository's main branch.</a:t>
             </a:r>
             <a:endParaRPr lang="en-US" sz="1300" dirty="0"/>
           </a:p>
@@ -10025,8 +10741,8 @@
         </p:nvSpPr>
         <p:spPr>
           <a:xfrm>
-            <a:off x="548640" y="4663440"/>
-            <a:ext cx="11064240" cy="822960"/>
+            <a:off x="640080" y="4114800"/>
+            <a:ext cx="10881360" cy="548640"/>
           </a:xfrm>
           <a:prstGeom prst="rect">
             <a:avLst/>
@@ -10050,7 +10766,7 @@
                 <a:ea typeface="Calibri" pitchFamily="34" charset="-122"/>
                 <a:cs typeface="Calibri" pitchFamily="34" charset="-120"/>
               </a:rPr>
-              <a:t>First deploy bootstraps infrastructure with a placeholder image (so ACR exists to push to); every subsequent run builds the real image first, then provisions/updates the Container App with that exact image — production is never left on the placeholder.</a:t>
+              <a:t>A separate smoke-test workflow triggers automatically after every successful deploy (and can be run manually), hitting /play and /api/scores on the live URL and reporting pass/fail.</a:t>
             </a:r>
             <a:endParaRPr lang="en-US" sz="1300" dirty="0"/>
           </a:p>
@@ -10064,8 +10780,8 @@
         </p:nvSpPr>
         <p:spPr>
           <a:xfrm>
-            <a:off x="0" y="5852160"/>
-            <a:ext cx="12188952" cy="1005840"/>
+            <a:off x="0" y="5120640"/>
+            <a:ext cx="12188952" cy="1371600"/>
           </a:xfrm>
           <a:prstGeom prst="rect">
             <a:avLst/>
@@ -10084,8 +10800,8 @@
         </p:nvSpPr>
         <p:spPr>
           <a:xfrm>
-            <a:off x="548640" y="5989320"/>
-            <a:ext cx="11064240" cy="731520"/>
+            <a:off x="548640" y="5257800"/>
+            <a:ext cx="11064240" cy="365760"/>
           </a:xfrm>
           <a:prstGeom prst="rect">
             <a:avLst/>
@@ -10101,17 +10817,56 @@
               <a:buNone/>
             </a:pPr>
             <a:r>
-              <a:rPr lang="en-US" sz="1300" dirty="0">
-                <a:solidFill>
-                  <a:srgbClr val="EAF4F4"/>
-                </a:solidFill>
-                <a:latin typeface="Calibri" pitchFamily="34" charset="0"/>
-                <a:ea typeface="Calibri" pitchFamily="34" charset="-122"/>
-                <a:cs typeface="Calibri" pitchFamily="34" charset="-120"/>
-              </a:rPr>
-              <a:t>Status at time of writing: Azure infra ticket (#14) in final review — production smoke test (#15) not yet run.</a:t>
-            </a:r>
-            <a:endParaRPr lang="en-US" sz="1300" dirty="0"/>
+              <a:rPr lang="en-US" sz="1400" b="1" dirty="0">
+                <a:solidFill>
+                  <a:srgbClr val="FFFFFF"/>
+                </a:solidFill>
+                <a:latin typeface="Trebuchet MS" pitchFamily="34" charset="0"/>
+                <a:ea typeface="Trebuchet MS" pitchFamily="34" charset="-122"/>
+                <a:cs typeface="Trebuchet MS" pitchFamily="34" charset="-120"/>
+              </a:rPr>
+              <a:t>Live production URL:</a:t>
+            </a:r>
+            <a:endParaRPr lang="en-US" sz="1400" dirty="0"/>
+          </a:p>
+        </p:txBody>
+      </p:sp>
+      <p:sp>
+        <p:nvSpPr>
+          <p:cNvPr id="22" name="Text 20"/>
+          <p:cNvSpPr/>
+          <p:nvPr/>
+        </p:nvSpPr>
+        <p:spPr>
+          <a:xfrm>
+            <a:off x="548640" y="5623560"/>
+            <a:ext cx="11064240" cy="457200"/>
+          </a:xfrm>
+          <a:prstGeom prst="rect">
+            <a:avLst/>
+          </a:prstGeom>
+          <a:noFill/>
+          <a:ln/>
+        </p:spPr>
+        <p:txBody>
+          <a:bodyPr wrap="square" lIns="0" tIns="0" rIns="0" bIns="0" rtlCol="0" anchor="ctr"/>
+          <a:lstStyle/>
+          <a:p>
+            <a:pPr indent="0" marL="0">
+              <a:buNone/>
+            </a:pPr>
+            <a:r>
+              <a:rPr lang="en-US" sz="1500" dirty="0">
+                <a:solidFill>
+                  <a:srgbClr val="3FA796"/>
+                </a:solidFill>
+                <a:latin typeface="Consolas" pitchFamily="34" charset="0"/>
+                <a:ea typeface="Consolas" pitchFamily="34" charset="-122"/>
+                <a:cs typeface="Consolas" pitchFamily="34" charset="-120"/>
+              </a:rPr>
+              <a:t>ca-ponpoko-eval.politecliff-3b621d61.koreacentral.azurecontainerapps.io</a:t>
+            </a:r>
+            <a:endParaRPr lang="en-US" sz="1500" dirty="0"/>
           </a:p>
         </p:txBody>
       </p:sp>

</xml_diff>